<commit_message>
added comparison of synthetic data to external existing datasets, improved synthetic data validation
</commit_message>
<xml_diff>
--- a/slides/LogTriage_Final.pptx
+++ b/slides/LogTriage_Final.pptx
@@ -844,7 +844,7 @@
           </a:prstGeom>
           <a:extLst>
             <a:ext uri="{C572A759-6A51-4108-AA02-DFA0A04FC94B}">
-              <ma14:wrappingTextBoxFlag xmlns:ma14="http://schemas.microsoft.com/office/mac/drawingml/2011/main" xmlns="" val="0"/>
+              <ma14:wrappingTextBoxFlag xmlns="" xmlns:ma14="http://schemas.microsoft.com/office/mac/drawingml/2011/main" val="0"/>
             </a:ext>
           </a:extLst>
         </p:spPr>
@@ -919,7 +919,7 @@
           </a:prstGeom>
           <a:extLst>
             <a:ext uri="{C572A759-6A51-4108-AA02-DFA0A04FC94B}">
-              <ma14:wrappingTextBoxFlag xmlns:ma14="http://schemas.microsoft.com/office/mac/drawingml/2011/main" xmlns="" val="0"/>
+              <ma14:wrappingTextBoxFlag xmlns="" xmlns:ma14="http://schemas.microsoft.com/office/mac/drawingml/2011/main" val="0"/>
             </a:ext>
           </a:extLst>
         </p:spPr>
@@ -1603,19 +1603,7 @@
                     <a:bodyPr/>
                     <a:lstStyle/>
                     <a:p>
-                      <a:pPr>
-                        <a:defRPr sz="1100" b="1">
-                          <a:solidFill>
-                            <a:srgbClr val="E8EEF8"/>
-                          </a:solidFill>
-                        </a:defRPr>
-                      </a:pPr>
                       <a:r>
-                        <a:rPr dirty="0">
-                          <a:solidFill>
-                            <a:schemeClr val="tx1"/>
-                          </a:solidFill>
-                        </a:rPr>
                         <a:t>Noise level</a:t>
                       </a:r>
                     </a:p>
@@ -1627,19 +1615,7 @@
                     <a:bodyPr/>
                     <a:lstStyle/>
                     <a:p>
-                      <a:pPr>
-                        <a:defRPr sz="1100" b="1">
-                          <a:solidFill>
-                            <a:srgbClr val="E8EEF8"/>
-                          </a:solidFill>
-                        </a:defRPr>
-                      </a:pPr>
                       <a:r>
-                        <a:rPr>
-                          <a:solidFill>
-                            <a:schemeClr val="tx1"/>
-                          </a:solidFill>
-                        </a:rPr>
                         <a:t>N</a:t>
                       </a:r>
                     </a:p>
@@ -1651,19 +1627,7 @@
                     <a:bodyPr/>
                     <a:lstStyle/>
                     <a:p>
-                      <a:pPr>
-                        <a:defRPr sz="1100" b="1">
-                          <a:solidFill>
-                            <a:srgbClr val="E8EEF8"/>
-                          </a:solidFill>
-                        </a:defRPr>
-                      </a:pPr>
                       <a:r>
-                        <a:rPr>
-                          <a:solidFill>
-                            <a:schemeClr val="tx1"/>
-                          </a:solidFill>
-                        </a:rPr>
                         <a:t>Severity F1</a:t>
                       </a:r>
                     </a:p>
@@ -1675,19 +1639,7 @@
                     <a:bodyPr/>
                     <a:lstStyle/>
                     <a:p>
-                      <a:pPr>
-                        <a:defRPr sz="1100" b="1">
-                          <a:solidFill>
-                            <a:srgbClr val="E8EEF8"/>
-                          </a:solidFill>
-                        </a:defRPr>
-                      </a:pPr>
                       <a:r>
-                        <a:rPr>
-                          <a:solidFill>
-                            <a:schemeClr val="tx1"/>
-                          </a:solidFill>
-                        </a:rPr>
                         <a:t>Full exact</a:t>
                       </a:r>
                     </a:p>
@@ -1706,19 +1658,7 @@
                     <a:bodyPr/>
                     <a:lstStyle/>
                     <a:p>
-                      <a:pPr>
-                        <a:defRPr sz="1000" b="0">
-                          <a:solidFill>
-                            <a:srgbClr val="E8EEF8"/>
-                          </a:solidFill>
-                        </a:defRPr>
-                      </a:pPr>
                       <a:r>
-                        <a:rPr dirty="0">
-                          <a:solidFill>
-                            <a:schemeClr val="tx1"/>
-                          </a:solidFill>
-                        </a:rPr>
                         <a:t>low</a:t>
                       </a:r>
                     </a:p>
@@ -1730,19 +1670,7 @@
                     <a:bodyPr/>
                     <a:lstStyle/>
                     <a:p>
-                      <a:pPr>
-                        <a:defRPr sz="1000" b="0">
-                          <a:solidFill>
-                            <a:srgbClr val="E8EEF8"/>
-                          </a:solidFill>
-                        </a:defRPr>
-                      </a:pPr>
                       <a:r>
-                        <a:rPr>
-                          <a:solidFill>
-                            <a:schemeClr val="tx1"/>
-                          </a:solidFill>
-                        </a:rPr>
                         <a:t>195</a:t>
                       </a:r>
                     </a:p>
@@ -1754,20 +1682,8 @@
                     <a:bodyPr/>
                     <a:lstStyle/>
                     <a:p>
-                      <a:pPr>
-                        <a:defRPr sz="1000" b="0">
-                          <a:solidFill>
-                            <a:srgbClr val="E8EEF8"/>
-                          </a:solidFill>
-                        </a:defRPr>
-                      </a:pPr>
                       <a:r>
-                        <a:rPr>
-                          <a:solidFill>
-                            <a:schemeClr val="tx1"/>
-                          </a:solidFill>
-                        </a:rPr>
-                        <a:t>0.650</a:t>
+                        <a:t>0.632</a:t>
                       </a:r>
                     </a:p>
                   </a:txBody>
@@ -1778,20 +1694,8 @@
                     <a:bodyPr/>
                     <a:lstStyle/>
                     <a:p>
-                      <a:pPr>
-                        <a:defRPr sz="1000" b="0">
-                          <a:solidFill>
-                            <a:srgbClr val="E8EEF8"/>
-                          </a:solidFill>
-                        </a:defRPr>
-                      </a:pPr>
                       <a:r>
-                        <a:rPr>
-                          <a:solidFill>
-                            <a:schemeClr val="tx1"/>
-                          </a:solidFill>
-                        </a:rPr>
-                        <a:t>0.569</a:t>
+                        <a:t>0.549</a:t>
                       </a:r>
                     </a:p>
                   </a:txBody>
@@ -1809,19 +1713,7 @@
                     <a:bodyPr/>
                     <a:lstStyle/>
                     <a:p>
-                      <a:pPr>
-                        <a:defRPr sz="1000" b="0">
-                          <a:solidFill>
-                            <a:srgbClr val="E8EEF8"/>
-                          </a:solidFill>
-                        </a:defRPr>
-                      </a:pPr>
                       <a:r>
-                        <a:rPr>
-                          <a:solidFill>
-                            <a:schemeClr val="tx1"/>
-                          </a:solidFill>
-                        </a:rPr>
                         <a:t>medium</a:t>
                       </a:r>
                     </a:p>
@@ -1833,19 +1725,7 @@
                     <a:bodyPr/>
                     <a:lstStyle/>
                     <a:p>
-                      <a:pPr>
-                        <a:defRPr sz="1000" b="0">
-                          <a:solidFill>
-                            <a:srgbClr val="E8EEF8"/>
-                          </a:solidFill>
-                        </a:defRPr>
-                      </a:pPr>
                       <a:r>
-                        <a:rPr dirty="0">
-                          <a:solidFill>
-                            <a:schemeClr val="tx1"/>
-                          </a:solidFill>
-                        </a:rPr>
                         <a:t>269</a:t>
                       </a:r>
                     </a:p>
@@ -1857,20 +1737,8 @@
                     <a:bodyPr/>
                     <a:lstStyle/>
                     <a:p>
-                      <a:pPr>
-                        <a:defRPr sz="1000" b="0">
-                          <a:solidFill>
-                            <a:srgbClr val="E8EEF8"/>
-                          </a:solidFill>
-                        </a:defRPr>
-                      </a:pPr>
                       <a:r>
-                        <a:rPr dirty="0">
-                          <a:solidFill>
-                            <a:schemeClr val="tx1"/>
-                          </a:solidFill>
-                        </a:rPr>
-                        <a:t>0.657</a:t>
+                        <a:t>0.645</a:t>
                       </a:r>
                     </a:p>
                   </a:txBody>
@@ -1881,20 +1749,8 @@
                     <a:bodyPr/>
                     <a:lstStyle/>
                     <a:p>
-                      <a:pPr>
-                        <a:defRPr sz="1000" b="0">
-                          <a:solidFill>
-                            <a:srgbClr val="E8EEF8"/>
-                          </a:solidFill>
-                        </a:defRPr>
-                      </a:pPr>
                       <a:r>
-                        <a:rPr>
-                          <a:solidFill>
-                            <a:schemeClr val="tx1"/>
-                          </a:solidFill>
-                        </a:rPr>
-                        <a:t>0.584</a:t>
+                        <a:t>0.569</a:t>
                       </a:r>
                     </a:p>
                   </a:txBody>
@@ -1912,19 +1768,7 @@
                     <a:bodyPr/>
                     <a:lstStyle/>
                     <a:p>
-                      <a:pPr>
-                        <a:defRPr sz="1000" b="0">
-                          <a:solidFill>
-                            <a:srgbClr val="E8EEF8"/>
-                          </a:solidFill>
-                        </a:defRPr>
-                      </a:pPr>
                       <a:r>
-                        <a:rPr>
-                          <a:solidFill>
-                            <a:schemeClr val="tx1"/>
-                          </a:solidFill>
-                        </a:rPr>
                         <a:t>high</a:t>
                       </a:r>
                     </a:p>
@@ -1936,19 +1780,7 @@
                     <a:bodyPr/>
                     <a:lstStyle/>
                     <a:p>
-                      <a:pPr>
-                        <a:defRPr sz="1000" b="0">
-                          <a:solidFill>
-                            <a:srgbClr val="E8EEF8"/>
-                          </a:solidFill>
-                        </a:defRPr>
-                      </a:pPr>
                       <a:r>
-                        <a:rPr>
-                          <a:solidFill>
-                            <a:schemeClr val="tx1"/>
-                          </a:solidFill>
-                        </a:rPr>
                         <a:t>203</a:t>
                       </a:r>
                     </a:p>
@@ -1960,20 +1792,8 @@
                     <a:bodyPr/>
                     <a:lstStyle/>
                     <a:p>
-                      <a:pPr>
-                        <a:defRPr sz="1000" b="0">
-                          <a:solidFill>
-                            <a:srgbClr val="E8EEF8"/>
-                          </a:solidFill>
-                        </a:defRPr>
-                      </a:pPr>
                       <a:r>
-                        <a:rPr dirty="0">
-                          <a:solidFill>
-                            <a:schemeClr val="tx1"/>
-                          </a:solidFill>
-                        </a:rPr>
-                        <a:t>0.645</a:t>
+                        <a:t>0.641</a:t>
                       </a:r>
                     </a:p>
                   </a:txBody>
@@ -1984,20 +1804,8 @@
                     <a:bodyPr/>
                     <a:lstStyle/>
                     <a:p>
-                      <a:pPr>
-                        <a:defRPr sz="1000" b="0">
-                          <a:solidFill>
-                            <a:srgbClr val="E8EEF8"/>
-                          </a:solidFill>
-                        </a:defRPr>
-                      </a:pPr>
                       <a:r>
-                        <a:rPr dirty="0">
-                          <a:solidFill>
-                            <a:schemeClr val="tx1"/>
-                          </a:solidFill>
-                        </a:rPr>
-                        <a:t>0.571</a:t>
+                        <a:t>0.567</a:t>
                       </a:r>
                     </a:p>
                   </a:txBody>
@@ -2057,7 +1865,7 @@
         <p:spPr>
           <a:xfrm>
             <a:off x="6400800" y="1892807"/>
-            <a:ext cx="5029200" cy="1569660"/>
+            <a:ext cx="5029200" cy="1754326"/>
           </a:xfrm>
           <a:prstGeom prst="rect">
             <a:avLst/>
@@ -2070,13 +1878,6 @@
           </a:bodyPr>
           <a:lstStyle/>
           <a:p>
-            <a:pPr>
-              <a:defRPr sz="1200" b="0">
-                <a:solidFill>
-                  <a:srgbClr val="E8EEF8"/>
-                </a:solidFill>
-              </a:defRPr>
-            </a:pPr>
             <a:r>
               <a:rPr dirty="0">
                 <a:solidFill>
@@ -2093,7 +1894,7 @@
                   <a:schemeClr val="bg2"/>
                 </a:solidFill>
               </a:rPr>
-              <a:t>• Severity F1 is stable (~0.645–0.657) but remains the bottleneck.</a:t>
+              <a:t>• Severity F1 is stable (~0.632–0.645) but remains the bottleneck.</a:t>
             </a:r>
           </a:p>
           <a:p>
@@ -2103,7 +1904,7 @@
                   <a:schemeClr val="bg2"/>
                 </a:solidFill>
               </a:rPr>
-              <a:t>• Full exact match stays near 57% — severity errors dominate end-to-end success.</a:t>
+              <a:t>• Full exact match stays near 56% — severity errors dominate end-to-end success.</a:t>
             </a:r>
           </a:p>
         </p:txBody>
@@ -2723,14 +2524,13 @@
           <a:bodyPr lIns="88900" rIns="88900" rtlCol="0" anchor="ctr"/>
           <a:lstStyle/>
           <a:p>
-            <a:pPr algn="ctr"/>
-            <a:r>
-              <a:rPr sz="900">
-                <a:solidFill>
-                  <a:srgbClr val="FFFFFF"/>
+            <a:r>
+              <a:rPr sz="900" dirty="0">
+                <a:solidFill>
+                  <a:schemeClr val="bg2"/>
                 </a:solidFill>
               </a:rPr>
-              <a:t>Generate less label-leaking logs, more paraphrases, and high-noise cases with misleading symptoms.</a:t>
+              <a:t>Label leakage was detected and fixed (500 sessions); validation pipeline added. Future: more paraphrases and misleading-noise cases.</a:t>
             </a:r>
           </a:p>
         </p:txBody>
@@ -2783,7 +2583,7 @@
           <p:nvPr>
             <p:extLst>
               <p:ext uri="{D42A27DB-BD31-4B8C-83A1-F6EECF244321}">
-                <p14:modId xmlns:p14="http://schemas.microsoft.com/office/powerpoint/2010/main" val="1145762112"/>
+                <p14:modId xmlns:p14="http://schemas.microsoft.com/office/powerpoint/2010/main" val="2191707935"/>
               </p:ext>
             </p:extLst>
           </p:nvPr>
@@ -2846,17 +2646,8 @@
                     <a:bodyPr/>
                     <a:lstStyle/>
                     <a:p>
-                      <a:pPr algn="l" rtl="0" fontAlgn="ctr">
-                        <a:buNone/>
-                      </a:pPr>
                       <a:r>
-                        <a:rPr lang="en-US" sz="1100" b="1" i="0" u="none" strike="noStrike" dirty="0">
-                          <a:solidFill>
-                            <a:srgbClr val="FFFFFF"/>
-                          </a:solidFill>
-                          <a:effectLst/>
-                          <a:latin typeface="Aptos" panose="020B0004020202020204" pitchFamily="34" charset="0"/>
-                        </a:rPr>
+                        <a:rPr sz="1200" dirty="0"/>
                         <a:t>Model</a:t>
                       </a:r>
                     </a:p>
@@ -2908,17 +2699,8 @@
                     <a:bodyPr/>
                     <a:lstStyle/>
                     <a:p>
-                      <a:pPr algn="ctr" rtl="0" fontAlgn="ctr">
-                        <a:buNone/>
-                      </a:pPr>
                       <a:r>
-                        <a:rPr lang="en-US" sz="1100" b="1" i="0" u="none" strike="noStrike">
-                          <a:solidFill>
-                            <a:srgbClr val="FFFFFF"/>
-                          </a:solidFill>
-                          <a:effectLst/>
-                          <a:latin typeface="Aptos" panose="020B0004020202020204" pitchFamily="34" charset="0"/>
-                        </a:rPr>
+                        <a:rPr sz="1200"/>
                         <a:t>Cause Acc</a:t>
                       </a:r>
                     </a:p>
@@ -2970,17 +2752,8 @@
                     <a:bodyPr/>
                     <a:lstStyle/>
                     <a:p>
-                      <a:pPr algn="ctr" rtl="0" fontAlgn="ctr">
-                        <a:buNone/>
-                      </a:pPr>
                       <a:r>
-                        <a:rPr lang="en-US" sz="1100" b="1" i="0" u="none" strike="noStrike">
-                          <a:solidFill>
-                            <a:srgbClr val="FFFFFF"/>
-                          </a:solidFill>
-                          <a:effectLst/>
-                          <a:latin typeface="Aptos" panose="020B0004020202020204" pitchFamily="34" charset="0"/>
-                        </a:rPr>
+                        <a:rPr sz="1200"/>
                         <a:t>Service Acc</a:t>
                       </a:r>
                     </a:p>
@@ -3032,17 +2805,8 @@
                     <a:bodyPr/>
                     <a:lstStyle/>
                     <a:p>
-                      <a:pPr algn="ctr" rtl="0" fontAlgn="ctr">
-                        <a:buNone/>
-                      </a:pPr>
                       <a:r>
-                        <a:rPr lang="en-US" sz="1100" b="1" i="0" u="none" strike="noStrike">
-                          <a:solidFill>
-                            <a:srgbClr val="FFFFFF"/>
-                          </a:solidFill>
-                          <a:effectLst/>
-                          <a:latin typeface="Aptos" panose="020B0004020202020204" pitchFamily="34" charset="0"/>
-                        </a:rPr>
+                        <a:rPr sz="1200"/>
                         <a:t>Severity Acc</a:t>
                       </a:r>
                     </a:p>
@@ -3094,17 +2858,8 @@
                     <a:bodyPr/>
                     <a:lstStyle/>
                     <a:p>
-                      <a:pPr algn="ctr" rtl="0" fontAlgn="ctr">
-                        <a:buNone/>
-                      </a:pPr>
                       <a:r>
-                        <a:rPr lang="en-US" sz="1100" b="1" i="0" u="none" strike="noStrike">
-                          <a:solidFill>
-                            <a:srgbClr val="FFFFFF"/>
-                          </a:solidFill>
-                          <a:effectLst/>
-                          <a:latin typeface="Aptos" panose="020B0004020202020204" pitchFamily="34" charset="0"/>
-                        </a:rPr>
+                        <a:rPr sz="1200"/>
                         <a:t>Action Acc</a:t>
                       </a:r>
                     </a:p>
@@ -3156,17 +2911,8 @@
                     <a:bodyPr/>
                     <a:lstStyle/>
                     <a:p>
-                      <a:pPr algn="ctr" rtl="0" fontAlgn="ctr">
-                        <a:buNone/>
-                      </a:pPr>
                       <a:r>
-                        <a:rPr lang="en-US" sz="1100" b="1" i="0" u="none" strike="noStrike">
-                          <a:solidFill>
-                            <a:srgbClr val="FFFFFF"/>
-                          </a:solidFill>
-                          <a:effectLst/>
-                          <a:latin typeface="Aptos" panose="020B0004020202020204" pitchFamily="34" charset="0"/>
-                        </a:rPr>
+                        <a:rPr sz="1200"/>
                         <a:t>Evidence P/R/F1</a:t>
                       </a:r>
                     </a:p>
@@ -3225,17 +2971,8 @@
                     <a:bodyPr/>
                     <a:lstStyle/>
                     <a:p>
-                      <a:pPr algn="l" rtl="0" fontAlgn="ctr">
-                        <a:buNone/>
-                      </a:pPr>
                       <a:r>
-                        <a:rPr lang="en-US" sz="1100" b="0" i="0" u="none" strike="noStrike">
-                          <a:solidFill>
-                            <a:srgbClr val="000000"/>
-                          </a:solidFill>
-                          <a:effectLst/>
-                          <a:latin typeface="Aptos" panose="020B0004020202020204" pitchFamily="34" charset="0"/>
-                        </a:rPr>
+                        <a:rPr sz="1200"/>
                         <a:t>Majority</a:t>
                       </a:r>
                     </a:p>
@@ -3287,17 +3024,8 @@
                     <a:bodyPr/>
                     <a:lstStyle/>
                     <a:p>
-                      <a:pPr algn="l" rtl="0" fontAlgn="ctr">
-                        <a:buNone/>
-                      </a:pPr>
                       <a:r>
-                        <a:rPr lang="en-US" sz="1100" b="0" i="0" u="none" strike="noStrike" dirty="0">
-                          <a:solidFill>
-                            <a:srgbClr val="000000"/>
-                          </a:solidFill>
-                          <a:effectLst/>
-                          <a:latin typeface="Aptos" panose="020B0004020202020204" pitchFamily="34" charset="0"/>
-                        </a:rPr>
+                        <a:rPr sz="1200"/>
                         <a:t>0.1</a:t>
                       </a:r>
                     </a:p>
@@ -3349,17 +3077,8 @@
                     <a:bodyPr/>
                     <a:lstStyle/>
                     <a:p>
-                      <a:pPr algn="l" rtl="0" fontAlgn="ctr">
-                        <a:buNone/>
-                      </a:pPr>
                       <a:r>
-                        <a:rPr lang="en-US" sz="1100" b="0" i="0" u="none" strike="noStrike">
-                          <a:solidFill>
-                            <a:srgbClr val="000000"/>
-                          </a:solidFill>
-                          <a:effectLst/>
-                          <a:latin typeface="Aptos" panose="020B0004020202020204" pitchFamily="34" charset="0"/>
-                        </a:rPr>
+                        <a:rPr sz="1200" dirty="0"/>
                         <a:t>0.3</a:t>
                       </a:r>
                     </a:p>
@@ -3411,17 +3130,8 @@
                     <a:bodyPr/>
                     <a:lstStyle/>
                     <a:p>
-                      <a:pPr algn="l" rtl="0" fontAlgn="ctr">
-                        <a:buNone/>
-                      </a:pPr>
                       <a:r>
-                        <a:rPr lang="en-US" sz="1100" b="0" i="0" u="none" strike="noStrike">
-                          <a:solidFill>
-                            <a:srgbClr val="000000"/>
-                          </a:solidFill>
-                          <a:effectLst/>
-                          <a:latin typeface="Aptos" panose="020B0004020202020204" pitchFamily="34" charset="0"/>
-                        </a:rPr>
+                        <a:rPr sz="1200"/>
                         <a:t>0.421</a:t>
                       </a:r>
                     </a:p>
@@ -3473,17 +3183,8 @@
                     <a:bodyPr/>
                     <a:lstStyle/>
                     <a:p>
-                      <a:pPr algn="l" rtl="0" fontAlgn="ctr">
-                        <a:buNone/>
-                      </a:pPr>
                       <a:r>
-                        <a:rPr lang="en-US" sz="1100" b="0" i="0" u="none" strike="noStrike">
-                          <a:solidFill>
-                            <a:srgbClr val="000000"/>
-                          </a:solidFill>
-                          <a:effectLst/>
-                          <a:latin typeface="Aptos" panose="020B0004020202020204" pitchFamily="34" charset="0"/>
-                        </a:rPr>
+                        <a:rPr sz="1200"/>
                         <a:t>0.1</a:t>
                       </a:r>
                     </a:p>
@@ -3535,17 +3236,8 @@
                     <a:bodyPr/>
                     <a:lstStyle/>
                     <a:p>
-                      <a:pPr algn="l" rtl="0" fontAlgn="ctr">
-                        <a:buNone/>
-                      </a:pPr>
                       <a:r>
-                        <a:rPr lang="en-US" sz="1100" b="0" i="0" u="none" strike="noStrike">
-                          <a:solidFill>
-                            <a:srgbClr val="000000"/>
-                          </a:solidFill>
-                          <a:effectLst/>
-                          <a:latin typeface="Aptos" panose="020B0004020202020204" pitchFamily="34" charset="0"/>
-                        </a:rPr>
+                        <a:rPr sz="1200"/>
                         <a:t>0.767/0.886/0.822</a:t>
                       </a:r>
                     </a:p>
@@ -3604,17 +3296,8 @@
                     <a:bodyPr/>
                     <a:lstStyle/>
                     <a:p>
-                      <a:pPr algn="l" rtl="0" fontAlgn="ctr">
-                        <a:buNone/>
-                      </a:pPr>
                       <a:r>
-                        <a:rPr lang="en-US" sz="1100" b="0" i="0" u="none" strike="noStrike" dirty="0">
-                          <a:solidFill>
-                            <a:srgbClr val="000000"/>
-                          </a:solidFill>
-                          <a:effectLst/>
-                          <a:latin typeface="Aptos" panose="020B0004020202020204" pitchFamily="34" charset="0"/>
-                        </a:rPr>
+                        <a:rPr sz="1200"/>
                         <a:t>Rules</a:t>
                       </a:r>
                     </a:p>
@@ -3666,17 +3349,8 @@
                     <a:bodyPr/>
                     <a:lstStyle/>
                     <a:p>
-                      <a:pPr algn="l" rtl="0" fontAlgn="ctr">
-                        <a:buNone/>
-                      </a:pPr>
                       <a:r>
-                        <a:rPr lang="en-US" sz="1100" b="0" i="0" u="none" strike="noStrike">
-                          <a:solidFill>
-                            <a:srgbClr val="000000"/>
-                          </a:solidFill>
-                          <a:effectLst/>
-                          <a:latin typeface="Aptos" panose="020B0004020202020204" pitchFamily="34" charset="0"/>
-                        </a:rPr>
+                        <a:rPr sz="1200"/>
                         <a:t>0.825</a:t>
                       </a:r>
                     </a:p>
@@ -3728,17 +3402,8 @@
                     <a:bodyPr/>
                     <a:lstStyle/>
                     <a:p>
-                      <a:pPr algn="l" rtl="0" fontAlgn="ctr">
-                        <a:buNone/>
-                      </a:pPr>
                       <a:r>
-                        <a:rPr lang="en-US" sz="1100" b="0" i="0" u="none" strike="noStrike" dirty="0">
-                          <a:solidFill>
-                            <a:srgbClr val="000000"/>
-                          </a:solidFill>
-                          <a:effectLst/>
-                          <a:latin typeface="Aptos" panose="020B0004020202020204" pitchFamily="34" charset="0"/>
-                        </a:rPr>
+                        <a:rPr sz="1200"/>
                         <a:t>0.412</a:t>
                       </a:r>
                     </a:p>
@@ -3790,17 +3455,8 @@
                     <a:bodyPr/>
                     <a:lstStyle/>
                     <a:p>
-                      <a:pPr algn="l" rtl="0" fontAlgn="ctr">
-                        <a:buNone/>
-                      </a:pPr>
                       <a:r>
-                        <a:rPr lang="en-US" sz="1100" b="0" i="0" u="none" strike="noStrike">
-                          <a:solidFill>
-                            <a:srgbClr val="000000"/>
-                          </a:solidFill>
-                          <a:effectLst/>
-                          <a:latin typeface="Aptos" panose="020B0004020202020204" pitchFamily="34" charset="0"/>
-                        </a:rPr>
+                        <a:rPr sz="1200" dirty="0"/>
                         <a:t>0.453</a:t>
                       </a:r>
                     </a:p>
@@ -3852,17 +3508,8 @@
                     <a:bodyPr/>
                     <a:lstStyle/>
                     <a:p>
-                      <a:pPr algn="l" rtl="0" fontAlgn="ctr">
-                        <a:buNone/>
-                      </a:pPr>
                       <a:r>
-                        <a:rPr lang="en-US" sz="1100" b="0" i="0" u="none" strike="noStrike">
-                          <a:solidFill>
-                            <a:srgbClr val="000000"/>
-                          </a:solidFill>
-                          <a:effectLst/>
-                          <a:latin typeface="Aptos" panose="020B0004020202020204" pitchFamily="34" charset="0"/>
-                        </a:rPr>
+                        <a:rPr sz="1200"/>
                         <a:t>0.825</a:t>
                       </a:r>
                     </a:p>
@@ -3914,17 +3561,8 @@
                     <a:bodyPr/>
                     <a:lstStyle/>
                     <a:p>
-                      <a:pPr algn="l" rtl="0" fontAlgn="ctr">
-                        <a:buNone/>
-                      </a:pPr>
                       <a:r>
-                        <a:rPr lang="en-US" sz="1100" b="0" i="0" u="none" strike="noStrike">
-                          <a:solidFill>
-                            <a:srgbClr val="000000"/>
-                          </a:solidFill>
-                          <a:effectLst/>
-                          <a:latin typeface="Aptos" panose="020B0004020202020204" pitchFamily="34" charset="0"/>
-                        </a:rPr>
+                        <a:rPr sz="1200"/>
                         <a:t>0.795/0.941/0.861</a:t>
                       </a:r>
                     </a:p>
@@ -3983,17 +3621,8 @@
                     <a:bodyPr/>
                     <a:lstStyle/>
                     <a:p>
-                      <a:pPr algn="l" rtl="0" fontAlgn="ctr">
-                        <a:buNone/>
-                      </a:pPr>
                       <a:r>
-                        <a:rPr lang="en-US" sz="1100" b="0" i="0" u="none" strike="noStrike">
-                          <a:solidFill>
-                            <a:srgbClr val="000000"/>
-                          </a:solidFill>
-                          <a:effectLst/>
-                          <a:latin typeface="Aptos" panose="020B0004020202020204" pitchFamily="34" charset="0"/>
-                        </a:rPr>
+                        <a:rPr sz="1200"/>
                         <a:t>TF-IDF LogReg</a:t>
                       </a:r>
                     </a:p>
@@ -4045,17 +3674,8 @@
                     <a:bodyPr/>
                     <a:lstStyle/>
                     <a:p>
-                      <a:pPr algn="l" rtl="0" fontAlgn="ctr">
-                        <a:buNone/>
-                      </a:pPr>
                       <a:r>
-                        <a:rPr lang="en-US" sz="1100" b="0" i="0" u="none" strike="noStrike">
-                          <a:solidFill>
-                            <a:srgbClr val="000000"/>
-                          </a:solidFill>
-                          <a:effectLst/>
-                          <a:latin typeface="Aptos" panose="020B0004020202020204" pitchFamily="34" charset="0"/>
-                        </a:rPr>
+                        <a:rPr sz="1200"/>
                         <a:t>1</a:t>
                       </a:r>
                     </a:p>
@@ -4107,17 +3727,8 @@
                     <a:bodyPr/>
                     <a:lstStyle/>
                     <a:p>
-                      <a:pPr algn="l" rtl="0" fontAlgn="ctr">
-                        <a:buNone/>
-                      </a:pPr>
                       <a:r>
-                        <a:rPr lang="en-US" sz="1100" b="0" i="0" u="none" strike="noStrike" dirty="0">
-                          <a:solidFill>
-                            <a:srgbClr val="000000"/>
-                          </a:solidFill>
-                          <a:effectLst/>
-                          <a:latin typeface="Aptos" panose="020B0004020202020204" pitchFamily="34" charset="0"/>
-                        </a:rPr>
+                        <a:rPr sz="1200"/>
                         <a:t>1</a:t>
                       </a:r>
                     </a:p>
@@ -4169,18 +3780,9 @@
                     <a:bodyPr/>
                     <a:lstStyle/>
                     <a:p>
-                      <a:pPr algn="l" rtl="0" fontAlgn="ctr">
-                        <a:buNone/>
-                      </a:pPr>
                       <a:r>
-                        <a:rPr lang="en-US" sz="1100" b="0" i="0" u="none" strike="noStrike">
-                          <a:solidFill>
-                            <a:srgbClr val="000000"/>
-                          </a:solidFill>
-                          <a:effectLst/>
-                          <a:latin typeface="Aptos" panose="020B0004020202020204" pitchFamily="34" charset="0"/>
-                        </a:rPr>
-                        <a:t>0.544</a:t>
+                        <a:rPr sz="1200"/>
+                        <a:t>0.545</a:t>
                       </a:r>
                     </a:p>
                   </a:txBody>
@@ -4231,17 +3833,8 @@
                     <a:bodyPr/>
                     <a:lstStyle/>
                     <a:p>
-                      <a:pPr algn="l" rtl="0" fontAlgn="ctr">
-                        <a:buNone/>
-                      </a:pPr>
                       <a:r>
-                        <a:rPr lang="en-US" sz="1100" b="0" i="0" u="none" strike="noStrike">
-                          <a:solidFill>
-                            <a:srgbClr val="000000"/>
-                          </a:solidFill>
-                          <a:effectLst/>
-                          <a:latin typeface="Aptos" panose="020B0004020202020204" pitchFamily="34" charset="0"/>
-                        </a:rPr>
+                        <a:rPr sz="1200" dirty="0"/>
                         <a:t>1</a:t>
                       </a:r>
                     </a:p>
@@ -4293,17 +3886,8 @@
                     <a:bodyPr/>
                     <a:lstStyle/>
                     <a:p>
-                      <a:pPr algn="l" rtl="0" fontAlgn="ctr">
-                        <a:buNone/>
-                      </a:pPr>
                       <a:r>
-                        <a:rPr lang="en-US" sz="1100" b="0" i="0" u="none" strike="noStrike">
-                          <a:solidFill>
-                            <a:srgbClr val="000000"/>
-                          </a:solidFill>
-                          <a:effectLst/>
-                          <a:latin typeface="Aptos" panose="020B0004020202020204" pitchFamily="34" charset="0"/>
-                        </a:rPr>
+                        <a:rPr sz="1200"/>
                         <a:t>0.838/0.940/0.886</a:t>
                       </a:r>
                     </a:p>
@@ -4362,17 +3946,8 @@
                     <a:bodyPr/>
                     <a:lstStyle/>
                     <a:p>
-                      <a:pPr algn="l" rtl="0" fontAlgn="ctr">
-                        <a:buNone/>
-                      </a:pPr>
                       <a:r>
-                        <a:rPr lang="en-US" sz="1100" b="0" i="0" u="none" strike="noStrike">
-                          <a:solidFill>
-                            <a:srgbClr val="000000"/>
-                          </a:solidFill>
-                          <a:effectLst/>
-                          <a:latin typeface="Aptos" panose="020B0004020202020204" pitchFamily="34" charset="0"/>
-                        </a:rPr>
+                        <a:rPr sz="1200"/>
                         <a:t>TF-IDF SVM</a:t>
                       </a:r>
                     </a:p>
@@ -4424,17 +3999,8 @@
                     <a:bodyPr/>
                     <a:lstStyle/>
                     <a:p>
-                      <a:pPr algn="l" rtl="0" fontAlgn="ctr">
-                        <a:buNone/>
-                      </a:pPr>
                       <a:r>
-                        <a:rPr lang="en-US" sz="1100" b="0" i="0" u="none" strike="noStrike">
-                          <a:solidFill>
-                            <a:srgbClr val="000000"/>
-                          </a:solidFill>
-                          <a:effectLst/>
-                          <a:latin typeface="Aptos" panose="020B0004020202020204" pitchFamily="34" charset="0"/>
-                        </a:rPr>
+                        <a:rPr sz="1200"/>
                         <a:t>1</a:t>
                       </a:r>
                     </a:p>
@@ -4486,17 +4052,8 @@
                     <a:bodyPr/>
                     <a:lstStyle/>
                     <a:p>
-                      <a:pPr algn="l" rtl="0" fontAlgn="ctr">
-                        <a:buNone/>
-                      </a:pPr>
                       <a:r>
-                        <a:rPr lang="en-US" sz="1100" b="0" i="0" u="none" strike="noStrike">
-                          <a:solidFill>
-                            <a:srgbClr val="000000"/>
-                          </a:solidFill>
-                          <a:effectLst/>
-                          <a:latin typeface="Aptos" panose="020B0004020202020204" pitchFamily="34" charset="0"/>
-                        </a:rPr>
+                        <a:rPr sz="1200"/>
                         <a:t>1</a:t>
                       </a:r>
                     </a:p>
@@ -4548,18 +4105,9 @@
                     <a:bodyPr/>
                     <a:lstStyle/>
                     <a:p>
-                      <a:pPr algn="l" rtl="0" fontAlgn="ctr">
-                        <a:buNone/>
-                      </a:pPr>
                       <a:r>
-                        <a:rPr lang="en-US" sz="1100" b="0" i="0" u="none" strike="noStrike">
-                          <a:solidFill>
-                            <a:srgbClr val="000000"/>
-                          </a:solidFill>
-                          <a:effectLst/>
-                          <a:latin typeface="Aptos" panose="020B0004020202020204" pitchFamily="34" charset="0"/>
-                        </a:rPr>
-                        <a:t>0.572</a:t>
+                        <a:rPr sz="1200"/>
+                        <a:t>0.561</a:t>
                       </a:r>
                     </a:p>
                   </a:txBody>
@@ -4610,17 +4158,8 @@
                     <a:bodyPr/>
                     <a:lstStyle/>
                     <a:p>
-                      <a:pPr algn="l" rtl="0" fontAlgn="ctr">
-                        <a:buNone/>
-                      </a:pPr>
                       <a:r>
-                        <a:rPr lang="en-US" sz="1100" b="0" i="0" u="none" strike="noStrike">
-                          <a:solidFill>
-                            <a:srgbClr val="000000"/>
-                          </a:solidFill>
-                          <a:effectLst/>
-                          <a:latin typeface="Aptos" panose="020B0004020202020204" pitchFamily="34" charset="0"/>
-                        </a:rPr>
+                        <a:rPr sz="1200" dirty="0"/>
                         <a:t>1</a:t>
                       </a:r>
                     </a:p>
@@ -4672,17 +4211,8 @@
                     <a:bodyPr/>
                     <a:lstStyle/>
                     <a:p>
-                      <a:pPr algn="l" rtl="0" fontAlgn="ctr">
-                        <a:buNone/>
-                      </a:pPr>
                       <a:r>
-                        <a:rPr lang="en-US" sz="1100" b="0" i="0" u="none" strike="noStrike">
-                          <a:solidFill>
-                            <a:srgbClr val="000000"/>
-                          </a:solidFill>
-                          <a:effectLst/>
-                          <a:latin typeface="Aptos" panose="020B0004020202020204" pitchFamily="34" charset="0"/>
-                        </a:rPr>
+                        <a:rPr sz="1200"/>
                         <a:t>0.838/0.940/0.886</a:t>
                       </a:r>
                     </a:p>
@@ -4741,17 +4271,8 @@
                     <a:bodyPr/>
                     <a:lstStyle/>
                     <a:p>
-                      <a:pPr algn="l" rtl="0" fontAlgn="ctr">
-                        <a:buNone/>
-                      </a:pPr>
                       <a:r>
-                        <a:rPr lang="en-US" sz="1100" b="0" i="0" u="none" strike="noStrike">
-                          <a:solidFill>
-                            <a:srgbClr val="000000"/>
-                          </a:solidFill>
-                          <a:effectLst/>
-                          <a:latin typeface="Aptos" panose="020B0004020202020204" pitchFamily="34" charset="0"/>
-                        </a:rPr>
+                        <a:rPr sz="1200"/>
                         <a:t>TF-IDF NB</a:t>
                       </a:r>
                     </a:p>
@@ -4803,17 +4324,8 @@
                     <a:bodyPr/>
                     <a:lstStyle/>
                     <a:p>
-                      <a:pPr algn="l" rtl="0" fontAlgn="ctr">
-                        <a:buNone/>
-                      </a:pPr>
                       <a:r>
-                        <a:rPr lang="en-US" sz="1100" b="0" i="0" u="none" strike="noStrike">
-                          <a:solidFill>
-                            <a:srgbClr val="000000"/>
-                          </a:solidFill>
-                          <a:effectLst/>
-                          <a:latin typeface="Aptos" panose="020B0004020202020204" pitchFamily="34" charset="0"/>
-                        </a:rPr>
+                        <a:rPr sz="1200"/>
                         <a:t>1</a:t>
                       </a:r>
                     </a:p>
@@ -4865,18 +4377,9 @@
                     <a:bodyPr/>
                     <a:lstStyle/>
                     <a:p>
-                      <a:pPr algn="l" rtl="0" fontAlgn="ctr">
-                        <a:buNone/>
-                      </a:pPr>
                       <a:r>
-                        <a:rPr lang="en-US" sz="1100" b="0" i="0" u="none" strike="noStrike">
-                          <a:solidFill>
-                            <a:srgbClr val="000000"/>
-                          </a:solidFill>
-                          <a:effectLst/>
-                          <a:latin typeface="Aptos" panose="020B0004020202020204" pitchFamily="34" charset="0"/>
-                        </a:rPr>
-                        <a:t>0.997</a:t>
+                        <a:rPr sz="1200"/>
+                        <a:t>1</a:t>
                       </a:r>
                     </a:p>
                   </a:txBody>
@@ -4927,17 +4430,8 @@
                     <a:bodyPr/>
                     <a:lstStyle/>
                     <a:p>
-                      <a:pPr algn="l" rtl="0" fontAlgn="ctr">
-                        <a:buNone/>
-                      </a:pPr>
                       <a:r>
-                        <a:rPr lang="en-US" sz="1100" b="0" i="0" u="none" strike="noStrike" dirty="0">
-                          <a:solidFill>
-                            <a:srgbClr val="000000"/>
-                          </a:solidFill>
-                          <a:effectLst/>
-                          <a:latin typeface="Aptos" panose="020B0004020202020204" pitchFamily="34" charset="0"/>
-                        </a:rPr>
+                        <a:rPr sz="1200"/>
                         <a:t>0.492</a:t>
                       </a:r>
                     </a:p>
@@ -4989,17 +4483,8 @@
                     <a:bodyPr/>
                     <a:lstStyle/>
                     <a:p>
-                      <a:pPr algn="l" rtl="0" fontAlgn="ctr">
-                        <a:buNone/>
-                      </a:pPr>
                       <a:r>
-                        <a:rPr lang="en-US" sz="1100" b="0" i="0" u="none" strike="noStrike">
-                          <a:solidFill>
-                            <a:srgbClr val="000000"/>
-                          </a:solidFill>
-                          <a:effectLst/>
-                          <a:latin typeface="Aptos" panose="020B0004020202020204" pitchFamily="34" charset="0"/>
-                        </a:rPr>
+                        <a:rPr sz="1200"/>
                         <a:t>1</a:t>
                       </a:r>
                     </a:p>
@@ -5051,17 +4536,8 @@
                     <a:bodyPr/>
                     <a:lstStyle/>
                     <a:p>
-                      <a:pPr algn="l" rtl="0" fontAlgn="ctr">
-                        <a:buNone/>
-                      </a:pPr>
                       <a:r>
-                        <a:rPr lang="en-US" sz="1100" b="0" i="0" u="none" strike="noStrike">
-                          <a:solidFill>
-                            <a:srgbClr val="000000"/>
-                          </a:solidFill>
-                          <a:effectLst/>
-                          <a:latin typeface="Aptos" panose="020B0004020202020204" pitchFamily="34" charset="0"/>
-                        </a:rPr>
+                        <a:rPr sz="1200" dirty="0"/>
                         <a:t>0.838/0.940/0.886</a:t>
                       </a:r>
                     </a:p>
@@ -5120,17 +4596,8 @@
                     <a:bodyPr/>
                     <a:lstStyle/>
                     <a:p>
-                      <a:pPr algn="l" rtl="0" fontAlgn="ctr">
-                        <a:buNone/>
-                      </a:pPr>
                       <a:r>
-                        <a:rPr lang="en-US" sz="1100" b="0" i="0" u="none" strike="noStrike">
-                          <a:solidFill>
-                            <a:srgbClr val="000000"/>
-                          </a:solidFill>
-                          <a:effectLst/>
-                          <a:latin typeface="Aptos" panose="020B0004020202020204" pitchFamily="34" charset="0"/>
-                        </a:rPr>
+                        <a:rPr sz="1200"/>
                         <a:t>Char SVM</a:t>
                       </a:r>
                     </a:p>
@@ -5182,17 +4649,8 @@
                     <a:bodyPr/>
                     <a:lstStyle/>
                     <a:p>
-                      <a:pPr algn="l" rtl="0" fontAlgn="ctr">
-                        <a:buNone/>
-                      </a:pPr>
                       <a:r>
-                        <a:rPr lang="en-US" sz="1100" b="0" i="0" u="none" strike="noStrike">
-                          <a:solidFill>
-                            <a:srgbClr val="000000"/>
-                          </a:solidFill>
-                          <a:effectLst/>
-                          <a:latin typeface="Aptos" panose="020B0004020202020204" pitchFamily="34" charset="0"/>
-                        </a:rPr>
+                        <a:rPr sz="1200"/>
                         <a:t>1</a:t>
                       </a:r>
                     </a:p>
@@ -5244,17 +4702,8 @@
                     <a:bodyPr/>
                     <a:lstStyle/>
                     <a:p>
-                      <a:pPr algn="l" rtl="0" fontAlgn="ctr">
-                        <a:buNone/>
-                      </a:pPr>
                       <a:r>
-                        <a:rPr lang="en-US" sz="1100" b="0" i="0" u="none" strike="noStrike">
-                          <a:solidFill>
-                            <a:srgbClr val="000000"/>
-                          </a:solidFill>
-                          <a:effectLst/>
-                          <a:latin typeface="Aptos" panose="020B0004020202020204" pitchFamily="34" charset="0"/>
-                        </a:rPr>
+                        <a:rPr sz="1200"/>
                         <a:t>1</a:t>
                       </a:r>
                     </a:p>
@@ -5306,18 +4755,9 @@
                     <a:bodyPr/>
                     <a:lstStyle/>
                     <a:p>
-                      <a:pPr algn="l" rtl="0" fontAlgn="ctr">
-                        <a:buNone/>
-                      </a:pPr>
                       <a:r>
-                        <a:rPr lang="en-US" sz="1100" b="0" i="0" u="none" strike="noStrike">
-                          <a:solidFill>
-                            <a:srgbClr val="000000"/>
-                          </a:solidFill>
-                          <a:effectLst/>
-                          <a:latin typeface="Aptos" panose="020B0004020202020204" pitchFamily="34" charset="0"/>
-                        </a:rPr>
-                        <a:t>0.552</a:t>
+                        <a:rPr sz="1200"/>
+                        <a:t>0.556</a:t>
                       </a:r>
                     </a:p>
                   </a:txBody>
@@ -5368,17 +4808,8 @@
                     <a:bodyPr/>
                     <a:lstStyle/>
                     <a:p>
-                      <a:pPr algn="l" rtl="0" fontAlgn="ctr">
-                        <a:buNone/>
-                      </a:pPr>
                       <a:r>
-                        <a:rPr lang="en-US" sz="1100" b="0" i="0" u="none" strike="noStrike" dirty="0">
-                          <a:solidFill>
-                            <a:srgbClr val="000000"/>
-                          </a:solidFill>
-                          <a:effectLst/>
-                          <a:latin typeface="Aptos" panose="020B0004020202020204" pitchFamily="34" charset="0"/>
-                        </a:rPr>
+                        <a:rPr sz="1200"/>
                         <a:t>1</a:t>
                       </a:r>
                     </a:p>
@@ -5430,17 +4861,8 @@
                     <a:bodyPr/>
                     <a:lstStyle/>
                     <a:p>
-                      <a:pPr algn="l" rtl="0" fontAlgn="ctr">
-                        <a:buNone/>
-                      </a:pPr>
                       <a:r>
-                        <a:rPr lang="en-US" sz="1100" b="0" i="0" u="none" strike="noStrike">
-                          <a:solidFill>
-                            <a:srgbClr val="000000"/>
-                          </a:solidFill>
-                          <a:effectLst/>
-                          <a:latin typeface="Aptos" panose="020B0004020202020204" pitchFamily="34" charset="0"/>
-                        </a:rPr>
+                        <a:rPr sz="1200" dirty="0"/>
                         <a:t>0.838/0.940/0.886</a:t>
                       </a:r>
                     </a:p>
@@ -5499,17 +4921,8 @@
                     <a:bodyPr/>
                     <a:lstStyle/>
                     <a:p>
-                      <a:pPr algn="l" rtl="0" fontAlgn="ctr">
-                        <a:buNone/>
-                      </a:pPr>
                       <a:r>
-                        <a:rPr lang="en-US" sz="1100" b="0" i="0" u="none" strike="noStrike">
-                          <a:solidFill>
-                            <a:srgbClr val="000000"/>
-                          </a:solidFill>
-                          <a:effectLst/>
-                          <a:latin typeface="Aptos" panose="020B0004020202020204" pitchFamily="34" charset="0"/>
-                        </a:rPr>
+                        <a:rPr sz="1200"/>
                         <a:t>LLM zero-shot</a:t>
                       </a:r>
                     </a:p>
@@ -5561,17 +4974,8 @@
                     <a:bodyPr/>
                     <a:lstStyle/>
                     <a:p>
-                      <a:pPr algn="l" rtl="0" fontAlgn="ctr">
-                        <a:buNone/>
-                      </a:pPr>
                       <a:r>
-                        <a:rPr lang="en-US" sz="1100" b="0" i="0" u="none" strike="noStrike">
-                          <a:solidFill>
-                            <a:srgbClr val="000000"/>
-                          </a:solidFill>
-                          <a:effectLst/>
-                          <a:latin typeface="Aptos" panose="020B0004020202020204" pitchFamily="34" charset="0"/>
-                        </a:rPr>
+                        <a:rPr sz="1200"/>
                         <a:t>1</a:t>
                       </a:r>
                     </a:p>
@@ -5623,17 +5027,8 @@
                     <a:bodyPr/>
                     <a:lstStyle/>
                     <a:p>
-                      <a:pPr algn="l" rtl="0" fontAlgn="ctr">
-                        <a:buNone/>
-                      </a:pPr>
                       <a:r>
-                        <a:rPr lang="en-US" sz="1100" b="0" i="0" u="none" strike="noStrike">
-                          <a:solidFill>
-                            <a:srgbClr val="000000"/>
-                          </a:solidFill>
-                          <a:effectLst/>
-                          <a:latin typeface="Aptos" panose="020B0004020202020204" pitchFamily="34" charset="0"/>
-                        </a:rPr>
+                        <a:rPr sz="1200"/>
                         <a:t>0.8</a:t>
                       </a:r>
                     </a:p>
@@ -5685,17 +5080,8 @@
                     <a:bodyPr/>
                     <a:lstStyle/>
                     <a:p>
-                      <a:pPr algn="l" rtl="0" fontAlgn="ctr">
-                        <a:buNone/>
-                      </a:pPr>
                       <a:r>
-                        <a:rPr lang="en-US" sz="1100" b="0" i="0" u="none" strike="noStrike">
-                          <a:solidFill>
-                            <a:srgbClr val="000000"/>
-                          </a:solidFill>
-                          <a:effectLst/>
-                          <a:latin typeface="Aptos" panose="020B0004020202020204" pitchFamily="34" charset="0"/>
-                        </a:rPr>
+                        <a:rPr sz="1200"/>
                         <a:t>0.367</a:t>
                       </a:r>
                     </a:p>
@@ -5747,17 +5133,8 @@
                     <a:bodyPr/>
                     <a:lstStyle/>
                     <a:p>
-                      <a:pPr algn="l" rtl="0" fontAlgn="ctr">
-                        <a:buNone/>
-                      </a:pPr>
                       <a:r>
-                        <a:rPr lang="en-US" sz="1100" b="0" i="0" u="none" strike="noStrike" dirty="0">
-                          <a:solidFill>
-                            <a:srgbClr val="000000"/>
-                          </a:solidFill>
-                          <a:effectLst/>
-                          <a:latin typeface="Aptos" panose="020B0004020202020204" pitchFamily="34" charset="0"/>
-                        </a:rPr>
+                        <a:rPr sz="1200"/>
                         <a:t>1</a:t>
                       </a:r>
                     </a:p>
@@ -5809,17 +5186,8 @@
                     <a:bodyPr/>
                     <a:lstStyle/>
                     <a:p>
-                      <a:pPr algn="l" rtl="0" fontAlgn="ctr">
-                        <a:buNone/>
-                      </a:pPr>
                       <a:r>
-                        <a:rPr lang="en-US" sz="1100" b="0" i="0" u="none" strike="noStrike" dirty="0">
-                          <a:solidFill>
-                            <a:srgbClr val="000000"/>
-                          </a:solidFill>
-                          <a:effectLst/>
-                          <a:latin typeface="Aptos" panose="020B0004020202020204" pitchFamily="34" charset="0"/>
-                        </a:rPr>
+                        <a:rPr sz="1200" dirty="0"/>
                         <a:t>0.989/0.900/0.942</a:t>
                       </a:r>
                     </a:p>
@@ -5878,17 +5246,8 @@
                     <a:bodyPr/>
                     <a:lstStyle/>
                     <a:p>
-                      <a:pPr algn="l" rtl="0" fontAlgn="ctr">
-                        <a:buNone/>
-                      </a:pPr>
                       <a:r>
-                        <a:rPr lang="en-US" sz="1100" b="0" i="0" u="none" strike="noStrike">
-                          <a:solidFill>
-                            <a:srgbClr val="000000"/>
-                          </a:solidFill>
-                          <a:effectLst/>
-                          <a:latin typeface="Aptos" panose="020B0004020202020204" pitchFamily="34" charset="0"/>
-                        </a:rPr>
+                        <a:rPr sz="1200"/>
                         <a:t>LLM few-shot</a:t>
                       </a:r>
                     </a:p>
@@ -5940,17 +5299,8 @@
                     <a:bodyPr/>
                     <a:lstStyle/>
                     <a:p>
-                      <a:pPr algn="l" rtl="0" fontAlgn="ctr">
-                        <a:buNone/>
-                      </a:pPr>
                       <a:r>
-                        <a:rPr lang="en-US" sz="1100" b="0" i="0" u="none" strike="noStrike">
-                          <a:solidFill>
-                            <a:srgbClr val="000000"/>
-                          </a:solidFill>
-                          <a:effectLst/>
-                          <a:latin typeface="Aptos" panose="020B0004020202020204" pitchFamily="34" charset="0"/>
-                        </a:rPr>
+                        <a:rPr sz="1200"/>
                         <a:t>1</a:t>
                       </a:r>
                     </a:p>
@@ -6002,17 +5352,8 @@
                     <a:bodyPr/>
                     <a:lstStyle/>
                     <a:p>
-                      <a:pPr algn="l" rtl="0" fontAlgn="ctr">
-                        <a:buNone/>
-                      </a:pPr>
                       <a:r>
-                        <a:rPr lang="en-US" sz="1100" b="0" i="0" u="none" strike="noStrike">
-                          <a:solidFill>
-                            <a:srgbClr val="000000"/>
-                          </a:solidFill>
-                          <a:effectLst/>
-                          <a:latin typeface="Aptos" panose="020B0004020202020204" pitchFamily="34" charset="0"/>
-                        </a:rPr>
+                        <a:rPr sz="1200"/>
                         <a:t>1</a:t>
                       </a:r>
                     </a:p>
@@ -6064,17 +5405,8 @@
                     <a:bodyPr/>
                     <a:lstStyle/>
                     <a:p>
-                      <a:pPr algn="l" rtl="0" fontAlgn="ctr">
-                        <a:buNone/>
-                      </a:pPr>
                       <a:r>
-                        <a:rPr lang="en-US" sz="1100" b="0" i="0" u="none" strike="noStrike">
-                          <a:solidFill>
-                            <a:srgbClr val="000000"/>
-                          </a:solidFill>
-                          <a:effectLst/>
-                          <a:latin typeface="Aptos" panose="020B0004020202020204" pitchFamily="34" charset="0"/>
-                        </a:rPr>
+                        <a:rPr sz="1200"/>
                         <a:t>0.533</a:t>
                       </a:r>
                     </a:p>
@@ -6126,17 +5458,8 @@
                     <a:bodyPr/>
                     <a:lstStyle/>
                     <a:p>
-                      <a:pPr algn="l" rtl="0" fontAlgn="ctr">
-                        <a:buNone/>
-                      </a:pPr>
                       <a:r>
-                        <a:rPr lang="en-US" sz="1100" b="0" i="0" u="none" strike="noStrike">
-                          <a:solidFill>
-                            <a:srgbClr val="000000"/>
-                          </a:solidFill>
-                          <a:effectLst/>
-                          <a:latin typeface="Aptos" panose="020B0004020202020204" pitchFamily="34" charset="0"/>
-                        </a:rPr>
+                        <a:rPr sz="1200"/>
                         <a:t>1</a:t>
                       </a:r>
                     </a:p>
@@ -6188,17 +5511,8 @@
                     <a:bodyPr/>
                     <a:lstStyle/>
                     <a:p>
-                      <a:pPr algn="l" rtl="0" fontAlgn="ctr">
-                        <a:buNone/>
-                      </a:pPr>
                       <a:r>
-                        <a:rPr lang="en-US" sz="1100" b="0" i="0" u="none" strike="noStrike" dirty="0">
-                          <a:solidFill>
-                            <a:srgbClr val="000000"/>
-                          </a:solidFill>
-                          <a:effectLst/>
-                          <a:latin typeface="Aptos" panose="020B0004020202020204" pitchFamily="34" charset="0"/>
-                        </a:rPr>
+                        <a:rPr sz="1200" dirty="0"/>
                         <a:t>0.990/0.990/0.990</a:t>
                       </a:r>
                     </a:p>
@@ -6257,17 +5571,8 @@
                     <a:bodyPr/>
                     <a:lstStyle/>
                     <a:p>
-                      <a:pPr algn="l" rtl="0" fontAlgn="ctr">
-                        <a:buNone/>
-                      </a:pPr>
                       <a:r>
-                        <a:rPr lang="en-US" sz="1100" b="0" i="0" u="none" strike="noStrike">
-                          <a:solidFill>
-                            <a:srgbClr val="000000"/>
-                          </a:solidFill>
-                          <a:effectLst/>
-                          <a:latin typeface="Aptos" panose="020B0004020202020204" pitchFamily="34" charset="0"/>
-                        </a:rPr>
+                        <a:rPr sz="1200"/>
                         <a:t>DistilRoBERTa</a:t>
                       </a:r>
                     </a:p>
@@ -6319,18 +5624,9 @@
                     <a:bodyPr/>
                     <a:lstStyle/>
                     <a:p>
-                      <a:pPr algn="l" rtl="0" fontAlgn="ctr">
-                        <a:buNone/>
-                      </a:pPr>
                       <a:r>
-                        <a:rPr lang="en-US" sz="1100" b="0" i="0" u="none" strike="noStrike">
-                          <a:solidFill>
-                            <a:srgbClr val="000000"/>
-                          </a:solidFill>
-                          <a:effectLst/>
-                          <a:latin typeface="Aptos" panose="020B0004020202020204" pitchFamily="34" charset="0"/>
-                        </a:rPr>
-                        <a:t>0.787</a:t>
+                        <a:rPr sz="1200"/>
+                        <a:t>0.72</a:t>
                       </a:r>
                     </a:p>
                   </a:txBody>
@@ -6381,18 +5677,9 @@
                     <a:bodyPr/>
                     <a:lstStyle/>
                     <a:p>
-                      <a:pPr algn="l" rtl="0" fontAlgn="ctr">
-                        <a:buNone/>
-                      </a:pPr>
                       <a:r>
-                        <a:rPr lang="en-US" sz="1100" b="0" i="0" u="none" strike="noStrike" dirty="0">
-                          <a:solidFill>
-                            <a:srgbClr val="000000"/>
-                          </a:solidFill>
-                          <a:effectLst/>
-                          <a:latin typeface="Aptos" panose="020B0004020202020204" pitchFamily="34" charset="0"/>
-                        </a:rPr>
-                        <a:t>0.44</a:t>
+                        <a:rPr sz="1200"/>
+                        <a:t>0.453</a:t>
                       </a:r>
                     </a:p>
                   </a:txBody>
@@ -6443,17 +5730,8 @@
                     <a:bodyPr/>
                     <a:lstStyle/>
                     <a:p>
-                      <a:pPr algn="l" rtl="0" fontAlgn="ctr">
-                        <a:buNone/>
-                      </a:pPr>
                       <a:r>
-                        <a:rPr lang="en-US" sz="1100" b="0" i="0" u="none" strike="noStrike">
-                          <a:solidFill>
-                            <a:srgbClr val="000000"/>
-                          </a:solidFill>
-                          <a:effectLst/>
-                          <a:latin typeface="Aptos" panose="020B0004020202020204" pitchFamily="34" charset="0"/>
-                        </a:rPr>
+                        <a:rPr sz="1200"/>
                         <a:t>0.347</a:t>
                       </a:r>
                     </a:p>
@@ -6505,17 +5783,8 @@
                     <a:bodyPr/>
                     <a:lstStyle/>
                     <a:p>
-                      <a:pPr algn="l" rtl="0" fontAlgn="ctr">
-                        <a:buNone/>
-                      </a:pPr>
                       <a:r>
-                        <a:rPr lang="en-US" sz="1100" b="0" i="0" u="none" strike="noStrike">
-                          <a:solidFill>
-                            <a:srgbClr val="000000"/>
-                          </a:solidFill>
-                          <a:effectLst/>
-                          <a:latin typeface="Aptos" panose="020B0004020202020204" pitchFamily="34" charset="0"/>
-                        </a:rPr>
+                        <a:rPr sz="1200"/>
                         <a:t>0.747</a:t>
                       </a:r>
                     </a:p>
@@ -6567,18 +5836,9 @@
                     <a:bodyPr/>
                     <a:lstStyle/>
                     <a:p>
-                      <a:pPr algn="l" rtl="0" fontAlgn="ctr">
-                        <a:buNone/>
-                      </a:pPr>
                       <a:r>
-                        <a:rPr lang="en-US" sz="1100" b="0" i="0" u="none" strike="noStrike" dirty="0">
-                          <a:solidFill>
-                            <a:srgbClr val="000000"/>
-                          </a:solidFill>
-                          <a:effectLst/>
-                          <a:latin typeface="Aptos" panose="020B0004020202020204" pitchFamily="34" charset="0"/>
-                        </a:rPr>
-                        <a:t>0.813/0.943/0.873</a:t>
+                        <a:rPr sz="1200" dirty="0"/>
+                        <a:t>0.817/0.947/0.877</a:t>
                       </a:r>
                     </a:p>
                   </a:txBody>
@@ -8007,7 +7267,7 @@
           </a:prstGeom>
           <a:extLst>
             <a:ext uri="{C572A759-6A51-4108-AA02-DFA0A04FC94B}">
-              <ma14:wrappingTextBoxFlag xmlns:ma14="http://schemas.microsoft.com/office/mac/drawingml/2011/main" xmlns="" val="0"/>
+              <ma14:wrappingTextBoxFlag xmlns="" xmlns:ma14="http://schemas.microsoft.com/office/mac/drawingml/2011/main" val="0"/>
             </a:ext>
           </a:extLst>
         </p:spPr>
@@ -8919,7 +8179,7 @@
           </a:prstGeom>
           <a:extLst>
             <a:ext uri="{C572A759-6A51-4108-AA02-DFA0A04FC94B}">
-              <ma14:wrappingTextBoxFlag xmlns:ma14="http://schemas.microsoft.com/office/mac/drawingml/2011/main" xmlns="" val="0"/>
+              <ma14:wrappingTextBoxFlag xmlns="" xmlns:ma14="http://schemas.microsoft.com/office/mac/drawingml/2011/main" val="0"/>
             </a:ext>
           </a:extLst>
         </p:spPr>
@@ -10328,7 +9588,7 @@
           </a:prstGeom>
           <a:extLst>
             <a:ext uri="{C572A759-6A51-4108-AA02-DFA0A04FC94B}">
-              <ma14:wrappingTextBoxFlag xmlns:ma14="http://schemas.microsoft.com/office/mac/drawingml/2011/main" xmlns="" val="0"/>
+              <ma14:wrappingTextBoxFlag xmlns="" xmlns:ma14="http://schemas.microsoft.com/office/mac/drawingml/2011/main" val="0"/>
             </a:ext>
           </a:extLst>
         </p:spPr>
@@ -15316,7 +14576,7 @@
           </a:prstGeom>
           <a:extLst>
             <a:ext uri="{C572A759-6A51-4108-AA02-DFA0A04FC94B}">
-              <ma14:wrappingTextBoxFlag xmlns:ma14="http://schemas.microsoft.com/office/mac/drawingml/2011/main" xmlns="" val="0"/>
+              <ma14:wrappingTextBoxFlag xmlns="" xmlns:ma14="http://schemas.microsoft.com/office/mac/drawingml/2011/main" val="0"/>
             </a:ext>
           </a:extLst>
         </p:spPr>
@@ -15758,8 +15018,28 @@
           <a:lstStyle/>
           <a:p>
             <a:r>
-              <a:rPr sz="900" dirty="0"/>
-              <a:t>evaluated (n=30)</a:t>
+              <a:rPr sz="780" dirty="0">
+                <a:solidFill>
+                  <a:srgbClr val="7DD3FC"/>
+                </a:solidFill>
+              </a:rPr>
+              <a:t>evaluated</a:t>
+            </a:r>
+            <a:r>
+              <a:rPr sz="900" dirty="0">
+                <a:solidFill>
+                  <a:schemeClr val="accent1"/>
+                </a:solidFill>
+              </a:rPr>
+              <a:t> </a:t>
+            </a:r>
+            <a:r>
+              <a:rPr sz="780" dirty="0">
+                <a:solidFill>
+                  <a:srgbClr val="7DD3FC"/>
+                </a:solidFill>
+              </a:rPr>
+              <a:t>(n=30)</a:t>
             </a:r>
           </a:p>
         </p:txBody>
@@ -15860,7 +15140,28 @@
           <a:lstStyle/>
           <a:p>
             <a:r>
-              <a:t>evaluated (n=75)</a:t>
+              <a:rPr sz="1300" dirty="0">
+                <a:solidFill>
+                  <a:srgbClr val="7DD3FC"/>
+                </a:solidFill>
+              </a:rPr>
+              <a:t>evaluated</a:t>
+            </a:r>
+            <a:r>
+              <a:rPr dirty="0">
+                <a:solidFill>
+                  <a:schemeClr val="accent1"/>
+                </a:solidFill>
+              </a:rPr>
+              <a:t> </a:t>
+            </a:r>
+            <a:r>
+              <a:rPr sz="1300" dirty="0">
+                <a:solidFill>
+                  <a:srgbClr val="7DD3FC"/>
+                </a:solidFill>
+              </a:rPr>
+              <a:t>(n=75)</a:t>
             </a:r>
           </a:p>
         </p:txBody>
@@ -16795,7 +16096,7 @@
           <a:p>
             <a:r>
               <a:rPr sz="900" dirty="0"/>
-              <a:t>Severity is lower: it depends on impact/context, not only words. Best real severity F1: 0.649 with Linear SVM.</a:t>
+              <a:t>Severity is lower: it depends on impact/context, not only words. Best real severity F1: 0.64 with Linear SVM.</a:t>
             </a:r>
           </a:p>
         </p:txBody>
@@ -17101,7 +16402,7 @@
           <a:p>
             <a:r>
               <a:rPr sz="900" dirty="0"/>
-              <a:t>Best local baseline (full n=750): TF-IDF SVM — 0.572 full exact. Best LLM (n=30): few-shot — 0.533. </a:t>
+              <a:t>Best local baseline (full n=750): TF-IDF SVM — 0.561 full exact. Best LLM (n=30): few-shot — 0.533. </a:t>
             </a:r>
             <a:r>
               <a:rPr sz="900" dirty="0" err="1"/>
@@ -17109,7 +16410,7 @@
             </a:r>
             <a:r>
               <a:rPr sz="900" dirty="0"/>
-              <a:t> (n=75): 0.080 full exact.</a:t>
+              <a:t> (n=75): 0.067 full exact.</a:t>
             </a:r>
           </a:p>
         </p:txBody>
@@ -17195,7 +16496,7 @@
           <p:nvPr>
             <p:extLst>
               <p:ext uri="{D42A27DB-BD31-4B8C-83A1-F6EECF244321}">
-                <p14:modId xmlns:p14="http://schemas.microsoft.com/office/powerpoint/2010/main" val="3006222966"/>
+                <p14:modId xmlns:p14="http://schemas.microsoft.com/office/powerpoint/2010/main" val="3389647348"/>
               </p:ext>
             </p:extLst>
           </p:nvPr>
@@ -17265,17 +16566,8 @@
                     <a:bodyPr/>
                     <a:lstStyle/>
                     <a:p>
-                      <a:pPr algn="l" rtl="0" fontAlgn="ctr">
-                        <a:buNone/>
-                      </a:pPr>
                       <a:r>
-                        <a:rPr lang="en-US" sz="1100" b="1" i="0" u="none" strike="noStrike" dirty="0">
-                          <a:solidFill>
-                            <a:srgbClr val="FFFFFF"/>
-                          </a:solidFill>
-                          <a:effectLst/>
-                          <a:latin typeface="Aptos" panose="020B0004020202020204" pitchFamily="34" charset="0"/>
-                        </a:rPr>
+                        <a:rPr sz="1200" dirty="0"/>
                         <a:t>Model</a:t>
                       </a:r>
                     </a:p>
@@ -17327,17 +16619,8 @@
                     <a:bodyPr/>
                     <a:lstStyle/>
                     <a:p>
-                      <a:pPr algn="ctr" rtl="0" fontAlgn="ctr">
-                        <a:buNone/>
-                      </a:pPr>
                       <a:r>
-                        <a:rPr lang="en-US" sz="1100" b="1" i="0" u="none" strike="noStrike">
-                          <a:solidFill>
-                            <a:srgbClr val="FFFFFF"/>
-                          </a:solidFill>
-                          <a:effectLst/>
-                          <a:latin typeface="Aptos" panose="020B0004020202020204" pitchFamily="34" charset="0"/>
-                        </a:rPr>
+                        <a:rPr sz="1200"/>
                         <a:t>Cause F1</a:t>
                       </a:r>
                     </a:p>
@@ -17389,17 +16672,8 @@
                     <a:bodyPr/>
                     <a:lstStyle/>
                     <a:p>
-                      <a:pPr algn="ctr" rtl="0" fontAlgn="ctr">
-                        <a:buNone/>
-                      </a:pPr>
                       <a:r>
-                        <a:rPr lang="en-US" sz="1100" b="1" i="0" u="none" strike="noStrike">
-                          <a:solidFill>
-                            <a:srgbClr val="FFFFFF"/>
-                          </a:solidFill>
-                          <a:effectLst/>
-                          <a:latin typeface="Aptos" panose="020B0004020202020204" pitchFamily="34" charset="0"/>
-                        </a:rPr>
+                        <a:rPr sz="1200"/>
                         <a:t>Service F1</a:t>
                       </a:r>
                     </a:p>
@@ -17451,17 +16725,8 @@
                     <a:bodyPr/>
                     <a:lstStyle/>
                     <a:p>
-                      <a:pPr algn="ctr" rtl="0" fontAlgn="ctr">
-                        <a:buNone/>
-                      </a:pPr>
                       <a:r>
-                        <a:rPr lang="en-US" sz="1100" b="1" i="0" u="none" strike="noStrike">
-                          <a:solidFill>
-                            <a:srgbClr val="FFFFFF"/>
-                          </a:solidFill>
-                          <a:effectLst/>
-                          <a:latin typeface="Aptos" panose="020B0004020202020204" pitchFamily="34" charset="0"/>
-                        </a:rPr>
+                        <a:rPr sz="1200"/>
                         <a:t>Severity F1</a:t>
                       </a:r>
                     </a:p>
@@ -17513,17 +16778,8 @@
                     <a:bodyPr/>
                     <a:lstStyle/>
                     <a:p>
-                      <a:pPr algn="ctr" rtl="0" fontAlgn="ctr">
-                        <a:buNone/>
-                      </a:pPr>
                       <a:r>
-                        <a:rPr lang="en-US" sz="1100" b="1" i="0" u="none" strike="noStrike">
-                          <a:solidFill>
-                            <a:srgbClr val="FFFFFF"/>
-                          </a:solidFill>
-                          <a:effectLst/>
-                          <a:latin typeface="Aptos" panose="020B0004020202020204" pitchFamily="34" charset="0"/>
-                        </a:rPr>
+                        <a:rPr sz="1200"/>
                         <a:t>Action F1</a:t>
                       </a:r>
                     </a:p>
@@ -17575,17 +16831,8 @@
                     <a:bodyPr/>
                     <a:lstStyle/>
                     <a:p>
-                      <a:pPr algn="ctr" rtl="0" fontAlgn="ctr">
-                        <a:buNone/>
-                      </a:pPr>
                       <a:r>
-                        <a:rPr lang="en-US" sz="1100" b="1" i="0" u="none" strike="noStrike">
-                          <a:solidFill>
-                            <a:srgbClr val="FFFFFF"/>
-                          </a:solidFill>
-                          <a:effectLst/>
-                          <a:latin typeface="Aptos" panose="020B0004020202020204" pitchFamily="34" charset="0"/>
-                        </a:rPr>
+                        <a:rPr sz="1200"/>
                         <a:t>Full exact</a:t>
                       </a:r>
                     </a:p>
@@ -17637,17 +16884,8 @@
                     <a:bodyPr/>
                     <a:lstStyle/>
                     <a:p>
-                      <a:pPr algn="ctr" rtl="0" fontAlgn="ctr">
-                        <a:buNone/>
-                      </a:pPr>
                       <a:r>
-                        <a:rPr lang="en-US" sz="1100" b="1" i="0" u="none" strike="noStrike">
-                          <a:solidFill>
-                            <a:srgbClr val="FFFFFF"/>
-                          </a:solidFill>
-                          <a:effectLst/>
-                          <a:latin typeface="Aptos" panose="020B0004020202020204" pitchFamily="34" charset="0"/>
-                        </a:rPr>
+                        <a:rPr sz="1200"/>
                         <a:t>Evidence F1</a:t>
                       </a:r>
                     </a:p>
@@ -17706,17 +16944,8 @@
                     <a:bodyPr/>
                     <a:lstStyle/>
                     <a:p>
-                      <a:pPr algn="l" rtl="0" fontAlgn="ctr">
-                        <a:buNone/>
-                      </a:pPr>
                       <a:r>
-                        <a:rPr lang="en-US" sz="1100" b="0" i="0" u="none" strike="noStrike" dirty="0">
-                          <a:solidFill>
-                            <a:srgbClr val="000000"/>
-                          </a:solidFill>
-                          <a:effectLst/>
-                          <a:latin typeface="Aptos" panose="020B0004020202020204" pitchFamily="34" charset="0"/>
-                        </a:rPr>
+                        <a:rPr sz="1200" dirty="0"/>
                         <a:t>Majority</a:t>
                       </a:r>
                     </a:p>
@@ -17768,17 +16997,8 @@
                     <a:bodyPr/>
                     <a:lstStyle/>
                     <a:p>
-                      <a:pPr algn="l" rtl="0" fontAlgn="ctr">
-                        <a:buNone/>
-                      </a:pPr>
                       <a:r>
-                        <a:rPr lang="en-US" sz="1100" b="0" i="0" u="none" strike="noStrike">
-                          <a:solidFill>
-                            <a:srgbClr val="000000"/>
-                          </a:solidFill>
-                          <a:effectLst/>
-                          <a:latin typeface="Aptos" panose="020B0004020202020204" pitchFamily="34" charset="0"/>
-                        </a:rPr>
+                        <a:rPr sz="1200"/>
                         <a:t>0.018</a:t>
                       </a:r>
                     </a:p>
@@ -17830,17 +17050,8 @@
                     <a:bodyPr/>
                     <a:lstStyle/>
                     <a:p>
-                      <a:pPr algn="l" rtl="0" fontAlgn="ctr">
-                        <a:buNone/>
-                      </a:pPr>
                       <a:r>
-                        <a:rPr lang="en-US" sz="1100" b="0" i="0" u="none" strike="noStrike">
-                          <a:solidFill>
-                            <a:srgbClr val="000000"/>
-                          </a:solidFill>
-                          <a:effectLst/>
-                          <a:latin typeface="Aptos" panose="020B0004020202020204" pitchFamily="34" charset="0"/>
-                        </a:rPr>
+                        <a:rPr sz="1200" dirty="0"/>
                         <a:t>0.066</a:t>
                       </a:r>
                     </a:p>
@@ -17892,17 +17103,8 @@
                     <a:bodyPr/>
                     <a:lstStyle/>
                     <a:p>
-                      <a:pPr algn="l" rtl="0" fontAlgn="ctr">
-                        <a:buNone/>
-                      </a:pPr>
                       <a:r>
-                        <a:rPr lang="en-US" sz="1100" b="0" i="0" u="none" strike="noStrike">
-                          <a:solidFill>
-                            <a:srgbClr val="000000"/>
-                          </a:solidFill>
-                          <a:effectLst/>
-                          <a:latin typeface="Aptos" panose="020B0004020202020204" pitchFamily="34" charset="0"/>
-                        </a:rPr>
+                        <a:rPr sz="1200"/>
                         <a:t>0.148</a:t>
                       </a:r>
                     </a:p>
@@ -17954,17 +17156,8 @@
                     <a:bodyPr/>
                     <a:lstStyle/>
                     <a:p>
-                      <a:pPr algn="l" rtl="0" fontAlgn="ctr">
-                        <a:buNone/>
-                      </a:pPr>
                       <a:r>
-                        <a:rPr lang="en-US" sz="1100" b="0" i="0" u="none" strike="noStrike">
-                          <a:solidFill>
-                            <a:srgbClr val="000000"/>
-                          </a:solidFill>
-                          <a:effectLst/>
-                          <a:latin typeface="Aptos" panose="020B0004020202020204" pitchFamily="34" charset="0"/>
-                        </a:rPr>
+                        <a:rPr sz="1200"/>
                         <a:t>0.018</a:t>
                       </a:r>
                     </a:p>
@@ -18016,17 +17209,8 @@
                     <a:bodyPr/>
                     <a:lstStyle/>
                     <a:p>
-                      <a:pPr algn="l" rtl="0" fontAlgn="ctr">
-                        <a:buNone/>
-                      </a:pPr>
                       <a:r>
-                        <a:rPr lang="en-US" sz="1100" b="0" i="0" u="none" strike="noStrike">
-                          <a:solidFill>
-                            <a:srgbClr val="000000"/>
-                          </a:solidFill>
-                          <a:effectLst/>
-                          <a:latin typeface="Aptos" panose="020B0004020202020204" pitchFamily="34" charset="0"/>
-                        </a:rPr>
+                        <a:rPr sz="1200"/>
                         <a:t>0</a:t>
                       </a:r>
                     </a:p>
@@ -18078,17 +17262,8 @@
                     <a:bodyPr/>
                     <a:lstStyle/>
                     <a:p>
-                      <a:pPr algn="l" rtl="0" fontAlgn="ctr">
-                        <a:buNone/>
-                      </a:pPr>
                       <a:r>
-                        <a:rPr lang="en-US" sz="1100" b="0" i="0" u="none" strike="noStrike">
-                          <a:solidFill>
-                            <a:srgbClr val="000000"/>
-                          </a:solidFill>
-                          <a:effectLst/>
-                          <a:latin typeface="Aptos" panose="020B0004020202020204" pitchFamily="34" charset="0"/>
-                        </a:rPr>
+                        <a:rPr sz="1200"/>
                         <a:t>0.822</a:t>
                       </a:r>
                     </a:p>
@@ -18147,17 +17322,8 @@
                     <a:bodyPr/>
                     <a:lstStyle/>
                     <a:p>
-                      <a:pPr algn="l" rtl="0" fontAlgn="ctr">
-                        <a:buNone/>
-                      </a:pPr>
                       <a:r>
-                        <a:rPr lang="en-US" sz="1100" b="0" i="0" u="none" strike="noStrike">
-                          <a:solidFill>
-                            <a:srgbClr val="000000"/>
-                          </a:solidFill>
-                          <a:effectLst/>
-                          <a:latin typeface="Aptos" panose="020B0004020202020204" pitchFamily="34" charset="0"/>
-                        </a:rPr>
+                        <a:rPr sz="1200"/>
                         <a:t>Rules</a:t>
                       </a:r>
                     </a:p>
@@ -18209,17 +17375,8 @@
                     <a:bodyPr/>
                     <a:lstStyle/>
                     <a:p>
-                      <a:pPr algn="l" rtl="0" fontAlgn="ctr">
-                        <a:buNone/>
-                      </a:pPr>
                       <a:r>
-                        <a:rPr lang="en-US" sz="1100" b="0" i="0" u="none" strike="noStrike">
-                          <a:solidFill>
-                            <a:srgbClr val="000000"/>
-                          </a:solidFill>
-                          <a:effectLst/>
-                          <a:latin typeface="Aptos" panose="020B0004020202020204" pitchFamily="34" charset="0"/>
-                        </a:rPr>
+                        <a:rPr sz="1200"/>
                         <a:t>0.804</a:t>
                       </a:r>
                     </a:p>
@@ -18271,17 +17428,8 @@
                     <a:bodyPr/>
                     <a:lstStyle/>
                     <a:p>
-                      <a:pPr algn="l" rtl="0" fontAlgn="ctr">
-                        <a:buNone/>
-                      </a:pPr>
                       <a:r>
-                        <a:rPr lang="en-US" sz="1100" b="0" i="0" u="none" strike="noStrike">
-                          <a:solidFill>
-                            <a:srgbClr val="000000"/>
-                          </a:solidFill>
-                          <a:effectLst/>
-                          <a:latin typeface="Aptos" panose="020B0004020202020204" pitchFamily="34" charset="0"/>
-                        </a:rPr>
+                        <a:rPr sz="1200"/>
                         <a:t>0.253</a:t>
                       </a:r>
                     </a:p>
@@ -18333,17 +17481,8 @@
                     <a:bodyPr/>
                     <a:lstStyle/>
                     <a:p>
-                      <a:pPr algn="l" rtl="0" fontAlgn="ctr">
-                        <a:buNone/>
-                      </a:pPr>
                       <a:r>
-                        <a:rPr lang="en-US" sz="1100" b="0" i="0" u="none" strike="noStrike">
-                          <a:solidFill>
-                            <a:srgbClr val="000000"/>
-                          </a:solidFill>
-                          <a:effectLst/>
-                          <a:latin typeface="Aptos" panose="020B0004020202020204" pitchFamily="34" charset="0"/>
-                        </a:rPr>
+                        <a:rPr sz="1200" dirty="0"/>
                         <a:t>0.481</a:t>
                       </a:r>
                     </a:p>
@@ -18395,17 +17534,8 @@
                     <a:bodyPr/>
                     <a:lstStyle/>
                     <a:p>
-                      <a:pPr algn="l" rtl="0" fontAlgn="ctr">
-                        <a:buNone/>
-                      </a:pPr>
                       <a:r>
-                        <a:rPr lang="en-US" sz="1100" b="0" i="0" u="none" strike="noStrike">
-                          <a:solidFill>
-                            <a:srgbClr val="000000"/>
-                          </a:solidFill>
-                          <a:effectLst/>
-                          <a:latin typeface="Aptos" panose="020B0004020202020204" pitchFamily="34" charset="0"/>
-                        </a:rPr>
+                        <a:rPr sz="1200"/>
                         <a:t>0.804</a:t>
                       </a:r>
                     </a:p>
@@ -18457,17 +17587,8 @@
                     <a:bodyPr/>
                     <a:lstStyle/>
                     <a:p>
-                      <a:pPr algn="l" rtl="0" fontAlgn="ctr">
-                        <a:buNone/>
-                      </a:pPr>
                       <a:r>
-                        <a:rPr lang="en-US" sz="1100" b="0" i="0" u="none" strike="noStrike">
-                          <a:solidFill>
-                            <a:srgbClr val="000000"/>
-                          </a:solidFill>
-                          <a:effectLst/>
-                          <a:latin typeface="Aptos" panose="020B0004020202020204" pitchFamily="34" charset="0"/>
-                        </a:rPr>
+                        <a:rPr sz="1200"/>
                         <a:t>0.175</a:t>
                       </a:r>
                     </a:p>
@@ -18519,17 +17640,8 @@
                     <a:bodyPr/>
                     <a:lstStyle/>
                     <a:p>
-                      <a:pPr algn="l" rtl="0" fontAlgn="ctr">
-                        <a:buNone/>
-                      </a:pPr>
                       <a:r>
-                        <a:rPr lang="en-US" sz="1100" b="0" i="0" u="none" strike="noStrike">
-                          <a:solidFill>
-                            <a:srgbClr val="000000"/>
-                          </a:solidFill>
-                          <a:effectLst/>
-                          <a:latin typeface="Aptos" panose="020B0004020202020204" pitchFamily="34" charset="0"/>
-                        </a:rPr>
+                        <a:rPr sz="1200"/>
                         <a:t>0.861</a:t>
                       </a:r>
                     </a:p>
@@ -18588,17 +17700,8 @@
                     <a:bodyPr/>
                     <a:lstStyle/>
                     <a:p>
-                      <a:pPr algn="l" rtl="0" fontAlgn="ctr">
-                        <a:buNone/>
-                      </a:pPr>
                       <a:r>
-                        <a:rPr lang="en-US" sz="1100" b="0" i="0" u="none" strike="noStrike">
-                          <a:solidFill>
-                            <a:srgbClr val="000000"/>
-                          </a:solidFill>
-                          <a:effectLst/>
-                          <a:latin typeface="Aptos" panose="020B0004020202020204" pitchFamily="34" charset="0"/>
-                        </a:rPr>
+                        <a:rPr sz="1200"/>
                         <a:t>TF-IDF LogReg</a:t>
                       </a:r>
                     </a:p>
@@ -18650,17 +17753,8 @@
                     <a:bodyPr/>
                     <a:lstStyle/>
                     <a:p>
-                      <a:pPr algn="l" rtl="0" fontAlgn="ctr">
-                        <a:buNone/>
-                      </a:pPr>
                       <a:r>
-                        <a:rPr lang="en-US" sz="1100" b="0" i="0" u="none" strike="noStrike">
-                          <a:solidFill>
-                            <a:srgbClr val="000000"/>
-                          </a:solidFill>
-                          <a:effectLst/>
-                          <a:latin typeface="Aptos" panose="020B0004020202020204" pitchFamily="34" charset="0"/>
-                        </a:rPr>
+                        <a:rPr sz="1200"/>
                         <a:t>1</a:t>
                       </a:r>
                     </a:p>
@@ -18712,17 +17806,8 @@
                     <a:bodyPr/>
                     <a:lstStyle/>
                     <a:p>
-                      <a:pPr algn="l" rtl="0" fontAlgn="ctr">
-                        <a:buNone/>
-                      </a:pPr>
                       <a:r>
-                        <a:rPr lang="en-US" sz="1100" b="0" i="0" u="none" strike="noStrike" dirty="0">
-                          <a:solidFill>
-                            <a:srgbClr val="000000"/>
-                          </a:solidFill>
-                          <a:effectLst/>
-                          <a:latin typeface="Aptos" panose="020B0004020202020204" pitchFamily="34" charset="0"/>
-                        </a:rPr>
+                        <a:rPr sz="1200"/>
                         <a:t>1</a:t>
                       </a:r>
                     </a:p>
@@ -18774,18 +17859,9 @@
                     <a:bodyPr/>
                     <a:lstStyle/>
                     <a:p>
-                      <a:pPr algn="l" rtl="0" fontAlgn="ctr">
-                        <a:buNone/>
-                      </a:pPr>
                       <a:r>
-                        <a:rPr lang="en-US" sz="1100" b="0" i="0" u="none" strike="noStrike">
-                          <a:solidFill>
-                            <a:srgbClr val="000000"/>
-                          </a:solidFill>
-                          <a:effectLst/>
-                          <a:latin typeface="Aptos" panose="020B0004020202020204" pitchFamily="34" charset="0"/>
-                        </a:rPr>
-                        <a:t>0.584</a:t>
+                        <a:rPr sz="1200"/>
+                        <a:t>0.585</a:t>
                       </a:r>
                     </a:p>
                   </a:txBody>
@@ -18836,17 +17912,8 @@
                     <a:bodyPr/>
                     <a:lstStyle/>
                     <a:p>
-                      <a:pPr algn="l" rtl="0" fontAlgn="ctr">
-                        <a:buNone/>
-                      </a:pPr>
                       <a:r>
-                        <a:rPr lang="en-US" sz="1100" b="0" i="0" u="none" strike="noStrike">
-                          <a:solidFill>
-                            <a:srgbClr val="000000"/>
-                          </a:solidFill>
-                          <a:effectLst/>
-                          <a:latin typeface="Aptos" panose="020B0004020202020204" pitchFamily="34" charset="0"/>
-                        </a:rPr>
+                        <a:rPr sz="1200" dirty="0"/>
                         <a:t>1</a:t>
                       </a:r>
                     </a:p>
@@ -18898,18 +17965,9 @@
                     <a:bodyPr/>
                     <a:lstStyle/>
                     <a:p>
-                      <a:pPr algn="l" rtl="0" fontAlgn="ctr">
-                        <a:buNone/>
-                      </a:pPr>
                       <a:r>
-                        <a:rPr lang="en-US" sz="1100" b="0" i="0" u="none" strike="noStrike">
-                          <a:solidFill>
-                            <a:srgbClr val="000000"/>
-                          </a:solidFill>
-                          <a:effectLst/>
-                          <a:latin typeface="Aptos" panose="020B0004020202020204" pitchFamily="34" charset="0"/>
-                        </a:rPr>
-                        <a:t>0.544</a:t>
+                        <a:rPr sz="1200"/>
+                        <a:t>0.545</a:t>
                       </a:r>
                     </a:p>
                   </a:txBody>
@@ -18960,17 +18018,8 @@
                     <a:bodyPr/>
                     <a:lstStyle/>
                     <a:p>
-                      <a:pPr algn="l" rtl="0" fontAlgn="ctr">
-                        <a:buNone/>
-                      </a:pPr>
                       <a:r>
-                        <a:rPr lang="en-US" sz="1100" b="0" i="0" u="none" strike="noStrike" dirty="0">
-                          <a:solidFill>
-                            <a:srgbClr val="000000"/>
-                          </a:solidFill>
-                          <a:effectLst/>
-                          <a:latin typeface="Aptos" panose="020B0004020202020204" pitchFamily="34" charset="0"/>
-                        </a:rPr>
+                        <a:rPr sz="1200"/>
                         <a:t>0.886</a:t>
                       </a:r>
                     </a:p>
@@ -19029,17 +18078,8 @@
                     <a:bodyPr/>
                     <a:lstStyle/>
                     <a:p>
-                      <a:pPr algn="l" rtl="0" fontAlgn="ctr">
-                        <a:buNone/>
-                      </a:pPr>
                       <a:r>
-                        <a:rPr lang="en-US" sz="1100" b="0" i="0" u="none" strike="noStrike">
-                          <a:solidFill>
-                            <a:srgbClr val="000000"/>
-                          </a:solidFill>
-                          <a:effectLst/>
-                          <a:latin typeface="Aptos" panose="020B0004020202020204" pitchFamily="34" charset="0"/>
-                        </a:rPr>
+                        <a:rPr sz="1200"/>
                         <a:t>TF-IDF SVM</a:t>
                       </a:r>
                     </a:p>
@@ -19091,17 +18131,8 @@
                     <a:bodyPr/>
                     <a:lstStyle/>
                     <a:p>
-                      <a:pPr algn="l" rtl="0" fontAlgn="ctr">
-                        <a:buNone/>
-                      </a:pPr>
                       <a:r>
-                        <a:rPr lang="en-US" sz="1100" b="0" i="0" u="none" strike="noStrike">
-                          <a:solidFill>
-                            <a:srgbClr val="000000"/>
-                          </a:solidFill>
-                          <a:effectLst/>
-                          <a:latin typeface="Aptos" panose="020B0004020202020204" pitchFamily="34" charset="0"/>
-                        </a:rPr>
+                        <a:rPr sz="1200"/>
                         <a:t>1</a:t>
                       </a:r>
                     </a:p>
@@ -19153,17 +18184,8 @@
                     <a:bodyPr/>
                     <a:lstStyle/>
                     <a:p>
-                      <a:pPr algn="l" rtl="0" fontAlgn="ctr">
-                        <a:buNone/>
-                      </a:pPr>
                       <a:r>
-                        <a:rPr lang="en-US" sz="1100" b="0" i="0" u="none" strike="noStrike">
-                          <a:solidFill>
-                            <a:srgbClr val="000000"/>
-                          </a:solidFill>
-                          <a:effectLst/>
-                          <a:latin typeface="Aptos" panose="020B0004020202020204" pitchFamily="34" charset="0"/>
-                        </a:rPr>
+                        <a:rPr sz="1200"/>
                         <a:t>1</a:t>
                       </a:r>
                     </a:p>
@@ -19215,18 +18237,9 @@
                     <a:bodyPr/>
                     <a:lstStyle/>
                     <a:p>
-                      <a:pPr algn="l" rtl="0" fontAlgn="ctr">
-                        <a:buNone/>
-                      </a:pPr>
                       <a:r>
-                        <a:rPr lang="en-US" sz="1100" b="0" i="0" u="none" strike="noStrike">
-                          <a:solidFill>
-                            <a:srgbClr val="000000"/>
-                          </a:solidFill>
-                          <a:effectLst/>
-                          <a:latin typeface="Aptos" panose="020B0004020202020204" pitchFamily="34" charset="0"/>
-                        </a:rPr>
-                        <a:t>0.649</a:t>
+                        <a:rPr sz="1200"/>
+                        <a:t>0.64</a:t>
                       </a:r>
                     </a:p>
                   </a:txBody>
@@ -19277,17 +18290,8 @@
                     <a:bodyPr/>
                     <a:lstStyle/>
                     <a:p>
-                      <a:pPr algn="l" rtl="0" fontAlgn="ctr">
-                        <a:buNone/>
-                      </a:pPr>
                       <a:r>
-                        <a:rPr lang="en-US" sz="1100" b="0" i="0" u="none" strike="noStrike">
-                          <a:solidFill>
-                            <a:srgbClr val="000000"/>
-                          </a:solidFill>
-                          <a:effectLst/>
-                          <a:latin typeface="Aptos" panose="020B0004020202020204" pitchFamily="34" charset="0"/>
-                        </a:rPr>
+                        <a:rPr sz="1200" dirty="0"/>
                         <a:t>1</a:t>
                       </a:r>
                     </a:p>
@@ -19339,18 +18343,9 @@
                     <a:bodyPr/>
                     <a:lstStyle/>
                     <a:p>
-                      <a:pPr algn="l" rtl="0" fontAlgn="ctr">
-                        <a:buNone/>
-                      </a:pPr>
                       <a:r>
-                        <a:rPr lang="en-US" sz="1100" b="0" i="0" u="none" strike="noStrike">
-                          <a:solidFill>
-                            <a:srgbClr val="000000"/>
-                          </a:solidFill>
-                          <a:effectLst/>
-                          <a:latin typeface="Aptos" panose="020B0004020202020204" pitchFamily="34" charset="0"/>
-                        </a:rPr>
-                        <a:t>0.572</a:t>
+                        <a:rPr sz="1200"/>
+                        <a:t>0.561</a:t>
                       </a:r>
                     </a:p>
                   </a:txBody>
@@ -19401,17 +18396,8 @@
                     <a:bodyPr/>
                     <a:lstStyle/>
                     <a:p>
-                      <a:pPr algn="l" rtl="0" fontAlgn="ctr">
-                        <a:buNone/>
-                      </a:pPr>
                       <a:r>
-                        <a:rPr lang="en-US" sz="1100" b="0" i="0" u="none" strike="noStrike">
-                          <a:solidFill>
-                            <a:srgbClr val="000000"/>
-                          </a:solidFill>
-                          <a:effectLst/>
-                          <a:latin typeface="Aptos" panose="020B0004020202020204" pitchFamily="34" charset="0"/>
-                        </a:rPr>
+                        <a:rPr sz="1200"/>
                         <a:t>0.886</a:t>
                       </a:r>
                     </a:p>
@@ -19470,17 +18456,8 @@
                     <a:bodyPr/>
                     <a:lstStyle/>
                     <a:p>
-                      <a:pPr algn="l" rtl="0" fontAlgn="ctr">
-                        <a:buNone/>
-                      </a:pPr>
                       <a:r>
-                        <a:rPr lang="en-US" sz="1100" b="0" i="0" u="none" strike="noStrike">
-                          <a:solidFill>
-                            <a:srgbClr val="000000"/>
-                          </a:solidFill>
-                          <a:effectLst/>
-                          <a:latin typeface="Aptos" panose="020B0004020202020204" pitchFamily="34" charset="0"/>
-                        </a:rPr>
+                        <a:rPr sz="1200"/>
                         <a:t>TF-IDF NB</a:t>
                       </a:r>
                     </a:p>
@@ -19532,17 +18509,8 @@
                     <a:bodyPr/>
                     <a:lstStyle/>
                     <a:p>
-                      <a:pPr algn="l" rtl="0" fontAlgn="ctr">
-                        <a:buNone/>
-                      </a:pPr>
                       <a:r>
-                        <a:rPr lang="en-US" sz="1100" b="0" i="0" u="none" strike="noStrike">
-                          <a:solidFill>
-                            <a:srgbClr val="000000"/>
-                          </a:solidFill>
-                          <a:effectLst/>
-                          <a:latin typeface="Aptos" panose="020B0004020202020204" pitchFamily="34" charset="0"/>
-                        </a:rPr>
+                        <a:rPr sz="1200"/>
                         <a:t>1</a:t>
                       </a:r>
                     </a:p>
@@ -19594,18 +18562,9 @@
                     <a:bodyPr/>
                     <a:lstStyle/>
                     <a:p>
-                      <a:pPr algn="l" rtl="0" fontAlgn="ctr">
-                        <a:buNone/>
-                      </a:pPr>
                       <a:r>
-                        <a:rPr lang="en-US" sz="1100" b="0" i="0" u="none" strike="noStrike">
-                          <a:solidFill>
-                            <a:srgbClr val="000000"/>
-                          </a:solidFill>
-                          <a:effectLst/>
-                          <a:latin typeface="Aptos" panose="020B0004020202020204" pitchFamily="34" charset="0"/>
-                        </a:rPr>
-                        <a:t>0.997</a:t>
+                        <a:rPr sz="1200"/>
+                        <a:t>1</a:t>
                       </a:r>
                     </a:p>
                   </a:txBody>
@@ -19656,17 +18615,8 @@
                     <a:bodyPr/>
                     <a:lstStyle/>
                     <a:p>
-                      <a:pPr algn="l" rtl="0" fontAlgn="ctr">
-                        <a:buNone/>
-                      </a:pPr>
                       <a:r>
-                        <a:rPr lang="en-US" sz="1100" b="0" i="0" u="none" strike="noStrike">
-                          <a:solidFill>
-                            <a:srgbClr val="000000"/>
-                          </a:solidFill>
-                          <a:effectLst/>
-                          <a:latin typeface="Aptos" panose="020B0004020202020204" pitchFamily="34" charset="0"/>
-                        </a:rPr>
+                        <a:rPr sz="1200"/>
                         <a:t>0.421</a:t>
                       </a:r>
                     </a:p>
@@ -19718,17 +18668,8 @@
                     <a:bodyPr/>
                     <a:lstStyle/>
                     <a:p>
-                      <a:pPr algn="l" rtl="0" fontAlgn="ctr">
-                        <a:buNone/>
-                      </a:pPr>
                       <a:r>
-                        <a:rPr lang="en-US" sz="1100" b="0" i="0" u="none" strike="noStrike" dirty="0">
-                          <a:solidFill>
-                            <a:srgbClr val="000000"/>
-                          </a:solidFill>
-                          <a:effectLst/>
-                          <a:latin typeface="Aptos" panose="020B0004020202020204" pitchFamily="34" charset="0"/>
-                        </a:rPr>
+                        <a:rPr sz="1200" dirty="0"/>
                         <a:t>1</a:t>
                       </a:r>
                     </a:p>
@@ -19780,17 +18721,8 @@
                     <a:bodyPr/>
                     <a:lstStyle/>
                     <a:p>
-                      <a:pPr algn="l" rtl="0" fontAlgn="ctr">
-                        <a:buNone/>
-                      </a:pPr>
                       <a:r>
-                        <a:rPr lang="en-US" sz="1100" b="0" i="0" u="none" strike="noStrike">
-                          <a:solidFill>
-                            <a:srgbClr val="000000"/>
-                          </a:solidFill>
-                          <a:effectLst/>
-                          <a:latin typeface="Aptos" panose="020B0004020202020204" pitchFamily="34" charset="0"/>
-                        </a:rPr>
+                        <a:rPr sz="1200" dirty="0"/>
                         <a:t>0.492</a:t>
                       </a:r>
                     </a:p>
@@ -19842,17 +18774,8 @@
                     <a:bodyPr/>
                     <a:lstStyle/>
                     <a:p>
-                      <a:pPr algn="l" rtl="0" fontAlgn="ctr">
-                        <a:buNone/>
-                      </a:pPr>
                       <a:r>
-                        <a:rPr lang="en-US" sz="1100" b="0" i="0" u="none" strike="noStrike">
-                          <a:solidFill>
-                            <a:srgbClr val="000000"/>
-                          </a:solidFill>
-                          <a:effectLst/>
-                          <a:latin typeface="Aptos" panose="020B0004020202020204" pitchFamily="34" charset="0"/>
-                        </a:rPr>
+                        <a:rPr sz="1200"/>
                         <a:t>0.886</a:t>
                       </a:r>
                     </a:p>
@@ -19911,17 +18834,8 @@
                     <a:bodyPr/>
                     <a:lstStyle/>
                     <a:p>
-                      <a:pPr algn="l" rtl="0" fontAlgn="ctr">
-                        <a:buNone/>
-                      </a:pPr>
                       <a:r>
-                        <a:rPr lang="en-US" sz="1100" b="0" i="0" u="none" strike="noStrike">
-                          <a:solidFill>
-                            <a:srgbClr val="000000"/>
-                          </a:solidFill>
-                          <a:effectLst/>
-                          <a:latin typeface="Aptos" panose="020B0004020202020204" pitchFamily="34" charset="0"/>
-                        </a:rPr>
+                        <a:rPr sz="1200"/>
                         <a:t>Char SVM</a:t>
                       </a:r>
                     </a:p>
@@ -19973,17 +18887,8 @@
                     <a:bodyPr/>
                     <a:lstStyle/>
                     <a:p>
-                      <a:pPr algn="l" rtl="0" fontAlgn="ctr">
-                        <a:buNone/>
-                      </a:pPr>
                       <a:r>
-                        <a:rPr lang="en-US" sz="1100" b="0" i="0" u="none" strike="noStrike">
-                          <a:solidFill>
-                            <a:srgbClr val="000000"/>
-                          </a:solidFill>
-                          <a:effectLst/>
-                          <a:latin typeface="Aptos" panose="020B0004020202020204" pitchFamily="34" charset="0"/>
-                        </a:rPr>
+                        <a:rPr sz="1200"/>
                         <a:t>1</a:t>
                       </a:r>
                     </a:p>
@@ -20035,17 +18940,8 @@
                     <a:bodyPr/>
                     <a:lstStyle/>
                     <a:p>
-                      <a:pPr algn="l" rtl="0" fontAlgn="ctr">
-                        <a:buNone/>
-                      </a:pPr>
                       <a:r>
-                        <a:rPr lang="en-US" sz="1100" b="0" i="0" u="none" strike="noStrike">
-                          <a:solidFill>
-                            <a:srgbClr val="000000"/>
-                          </a:solidFill>
-                          <a:effectLst/>
-                          <a:latin typeface="Aptos" panose="020B0004020202020204" pitchFamily="34" charset="0"/>
-                        </a:rPr>
+                        <a:rPr sz="1200"/>
                         <a:t>1</a:t>
                       </a:r>
                     </a:p>
@@ -20097,18 +18993,9 @@
                     <a:bodyPr/>
                     <a:lstStyle/>
                     <a:p>
-                      <a:pPr algn="l" rtl="0" fontAlgn="ctr">
-                        <a:buNone/>
-                      </a:pPr>
                       <a:r>
-                        <a:rPr lang="en-US" sz="1100" b="0" i="0" u="none" strike="noStrike">
-                          <a:solidFill>
-                            <a:srgbClr val="000000"/>
-                          </a:solidFill>
-                          <a:effectLst/>
-                          <a:latin typeface="Aptos" panose="020B0004020202020204" pitchFamily="34" charset="0"/>
-                        </a:rPr>
-                        <a:t>0.609</a:t>
+                        <a:rPr sz="1200"/>
+                        <a:t>0.607</a:t>
                       </a:r>
                     </a:p>
                   </a:txBody>
@@ -20159,17 +19046,8 @@
                     <a:bodyPr/>
                     <a:lstStyle/>
                     <a:p>
-                      <a:pPr algn="l" rtl="0" fontAlgn="ctr">
-                        <a:buNone/>
-                      </a:pPr>
                       <a:r>
-                        <a:rPr lang="en-US" sz="1100" b="0" i="0" u="none" strike="noStrike" dirty="0">
-                          <a:solidFill>
-                            <a:srgbClr val="000000"/>
-                          </a:solidFill>
-                          <a:effectLst/>
-                          <a:latin typeface="Aptos" panose="020B0004020202020204" pitchFamily="34" charset="0"/>
-                        </a:rPr>
+                        <a:rPr sz="1200"/>
                         <a:t>1</a:t>
                       </a:r>
                     </a:p>
@@ -20221,18 +19099,9 @@
                     <a:bodyPr/>
                     <a:lstStyle/>
                     <a:p>
-                      <a:pPr algn="l" rtl="0" fontAlgn="ctr">
-                        <a:buNone/>
-                      </a:pPr>
                       <a:r>
-                        <a:rPr lang="en-US" sz="1100" b="0" i="0" u="none" strike="noStrike">
-                          <a:solidFill>
-                            <a:srgbClr val="000000"/>
-                          </a:solidFill>
-                          <a:effectLst/>
-                          <a:latin typeface="Aptos" panose="020B0004020202020204" pitchFamily="34" charset="0"/>
-                        </a:rPr>
-                        <a:t>0.552</a:t>
+                        <a:rPr sz="1200" dirty="0"/>
+                        <a:t>0.556</a:t>
                       </a:r>
                     </a:p>
                   </a:txBody>
@@ -20283,17 +19152,8 @@
                     <a:bodyPr/>
                     <a:lstStyle/>
                     <a:p>
-                      <a:pPr algn="l" rtl="0" fontAlgn="ctr">
-                        <a:buNone/>
-                      </a:pPr>
                       <a:r>
-                        <a:rPr lang="en-US" sz="1100" b="0" i="0" u="none" strike="noStrike">
-                          <a:solidFill>
-                            <a:srgbClr val="000000"/>
-                          </a:solidFill>
-                          <a:effectLst/>
-                          <a:latin typeface="Aptos" panose="020B0004020202020204" pitchFamily="34" charset="0"/>
-                        </a:rPr>
+                        <a:rPr sz="1200"/>
                         <a:t>0.886</a:t>
                       </a:r>
                     </a:p>
@@ -20352,17 +19212,8 @@
                     <a:bodyPr/>
                     <a:lstStyle/>
                     <a:p>
-                      <a:pPr algn="l" rtl="0" fontAlgn="ctr">
-                        <a:buNone/>
-                      </a:pPr>
                       <a:r>
-                        <a:rPr lang="en-US" sz="1100" b="0" i="0" u="none" strike="noStrike">
-                          <a:solidFill>
-                            <a:srgbClr val="000000"/>
-                          </a:solidFill>
-                          <a:effectLst/>
-                          <a:latin typeface="Aptos" panose="020B0004020202020204" pitchFamily="34" charset="0"/>
-                        </a:rPr>
+                        <a:rPr sz="1200"/>
                         <a:t>LLM zero-shot</a:t>
                       </a:r>
                     </a:p>
@@ -20414,17 +19265,8 @@
                     <a:bodyPr/>
                     <a:lstStyle/>
                     <a:p>
-                      <a:pPr algn="l" rtl="0" fontAlgn="ctr">
-                        <a:buNone/>
-                      </a:pPr>
                       <a:r>
-                        <a:rPr lang="en-US" sz="1100" b="0" i="0" u="none" strike="noStrike">
-                          <a:solidFill>
-                            <a:srgbClr val="000000"/>
-                          </a:solidFill>
-                          <a:effectLst/>
-                          <a:latin typeface="Aptos" panose="020B0004020202020204" pitchFamily="34" charset="0"/>
-                        </a:rPr>
+                        <a:rPr sz="1200"/>
                         <a:t>1</a:t>
                       </a:r>
                     </a:p>
@@ -20476,17 +19318,8 @@
                     <a:bodyPr/>
                     <a:lstStyle/>
                     <a:p>
-                      <a:pPr algn="l" rtl="0" fontAlgn="ctr">
-                        <a:buNone/>
-                      </a:pPr>
                       <a:r>
-                        <a:rPr lang="en-US" sz="1100" b="0" i="0" u="none" strike="noStrike">
-                          <a:solidFill>
-                            <a:srgbClr val="000000"/>
-                          </a:solidFill>
-                          <a:effectLst/>
-                          <a:latin typeface="Aptos" panose="020B0004020202020204" pitchFamily="34" charset="0"/>
-                        </a:rPr>
+                        <a:rPr sz="1200"/>
                         <a:t>0.734</a:t>
                       </a:r>
                     </a:p>
@@ -20538,17 +19371,8 @@
                     <a:bodyPr/>
                     <a:lstStyle/>
                     <a:p>
-                      <a:pPr algn="l" rtl="0" fontAlgn="ctr">
-                        <a:buNone/>
-                      </a:pPr>
                       <a:r>
-                        <a:rPr lang="en-US" sz="1100" b="0" i="0" u="none" strike="noStrike">
-                          <a:solidFill>
-                            <a:srgbClr val="000000"/>
-                          </a:solidFill>
-                          <a:effectLst/>
-                          <a:latin typeface="Aptos" panose="020B0004020202020204" pitchFamily="34" charset="0"/>
-                        </a:rPr>
+                        <a:rPr sz="1200"/>
                         <a:t>0.441</a:t>
                       </a:r>
                     </a:p>
@@ -20600,17 +19424,8 @@
                     <a:bodyPr/>
                     <a:lstStyle/>
                     <a:p>
-                      <a:pPr algn="l" rtl="0" fontAlgn="ctr">
-                        <a:buNone/>
-                      </a:pPr>
                       <a:r>
-                        <a:rPr lang="en-US" sz="1100" b="0" i="0" u="none" strike="noStrike">
-                          <a:solidFill>
-                            <a:srgbClr val="000000"/>
-                          </a:solidFill>
-                          <a:effectLst/>
-                          <a:latin typeface="Aptos" panose="020B0004020202020204" pitchFamily="34" charset="0"/>
-                        </a:rPr>
+                        <a:rPr sz="1200"/>
                         <a:t>1</a:t>
                       </a:r>
                     </a:p>
@@ -20662,17 +19477,8 @@
                     <a:bodyPr/>
                     <a:lstStyle/>
                     <a:p>
-                      <a:pPr algn="l" rtl="0" fontAlgn="ctr">
-                        <a:buNone/>
-                      </a:pPr>
                       <a:r>
-                        <a:rPr lang="en-US" sz="1100" b="0" i="0" u="none" strike="noStrike" dirty="0">
-                          <a:solidFill>
-                            <a:srgbClr val="000000"/>
-                          </a:solidFill>
-                          <a:effectLst/>
-                          <a:latin typeface="Aptos" panose="020B0004020202020204" pitchFamily="34" charset="0"/>
-                        </a:rPr>
+                        <a:rPr sz="1200" dirty="0"/>
                         <a:t>0.3</a:t>
                       </a:r>
                     </a:p>
@@ -20724,17 +19530,8 @@
                     <a:bodyPr/>
                     <a:lstStyle/>
                     <a:p>
-                      <a:pPr algn="l" rtl="0" fontAlgn="ctr">
-                        <a:buNone/>
-                      </a:pPr>
                       <a:r>
-                        <a:rPr lang="en-US" sz="1100" b="0" i="0" u="none" strike="noStrike">
-                          <a:solidFill>
-                            <a:srgbClr val="000000"/>
-                          </a:solidFill>
-                          <a:effectLst/>
-                          <a:latin typeface="Aptos" panose="020B0004020202020204" pitchFamily="34" charset="0"/>
-                        </a:rPr>
+                        <a:rPr sz="1200"/>
                         <a:t>0.942</a:t>
                       </a:r>
                     </a:p>
@@ -20793,17 +19590,8 @@
                     <a:bodyPr/>
                     <a:lstStyle/>
                     <a:p>
-                      <a:pPr algn="l" rtl="0" fontAlgn="ctr">
-                        <a:buNone/>
-                      </a:pPr>
                       <a:r>
-                        <a:rPr lang="en-US" sz="1100" b="0" i="0" u="none" strike="noStrike">
-                          <a:solidFill>
-                            <a:srgbClr val="000000"/>
-                          </a:solidFill>
-                          <a:effectLst/>
-                          <a:latin typeface="Aptos" panose="020B0004020202020204" pitchFamily="34" charset="0"/>
-                        </a:rPr>
+                        <a:rPr sz="1200"/>
                         <a:t>LLM few-shot</a:t>
                       </a:r>
                     </a:p>
@@ -20855,17 +19643,8 @@
                     <a:bodyPr/>
                     <a:lstStyle/>
                     <a:p>
-                      <a:pPr algn="l" rtl="0" fontAlgn="ctr">
-                        <a:buNone/>
-                      </a:pPr>
                       <a:r>
-                        <a:rPr lang="en-US" sz="1100" b="0" i="0" u="none" strike="noStrike">
-                          <a:solidFill>
-                            <a:srgbClr val="000000"/>
-                          </a:solidFill>
-                          <a:effectLst/>
-                          <a:latin typeface="Aptos" panose="020B0004020202020204" pitchFamily="34" charset="0"/>
-                        </a:rPr>
+                        <a:rPr sz="1200"/>
                         <a:t>1</a:t>
                       </a:r>
                     </a:p>
@@ -20917,17 +19696,8 @@
                     <a:bodyPr/>
                     <a:lstStyle/>
                     <a:p>
-                      <a:pPr algn="l" rtl="0" fontAlgn="ctr">
-                        <a:buNone/>
-                      </a:pPr>
                       <a:r>
-                        <a:rPr lang="en-US" sz="1100" b="0" i="0" u="none" strike="noStrike">
-                          <a:solidFill>
-                            <a:srgbClr val="000000"/>
-                          </a:solidFill>
-                          <a:effectLst/>
-                          <a:latin typeface="Aptos" panose="020B0004020202020204" pitchFamily="34" charset="0"/>
-                        </a:rPr>
+                        <a:rPr sz="1200"/>
                         <a:t>1</a:t>
                       </a:r>
                     </a:p>
@@ -20979,17 +19749,8 @@
                     <a:bodyPr/>
                     <a:lstStyle/>
                     <a:p>
-                      <a:pPr algn="l" rtl="0" fontAlgn="ctr">
-                        <a:buNone/>
-                      </a:pPr>
                       <a:r>
-                        <a:rPr lang="en-US" sz="1100" b="0" i="0" u="none" strike="noStrike">
-                          <a:solidFill>
-                            <a:srgbClr val="000000"/>
-                          </a:solidFill>
-                          <a:effectLst/>
-                          <a:latin typeface="Aptos" panose="020B0004020202020204" pitchFamily="34" charset="0"/>
-                        </a:rPr>
+                        <a:rPr sz="1200"/>
                         <a:t>0.643</a:t>
                       </a:r>
                     </a:p>
@@ -21041,17 +19802,8 @@
                     <a:bodyPr/>
                     <a:lstStyle/>
                     <a:p>
-                      <a:pPr algn="l" rtl="0" fontAlgn="ctr">
-                        <a:buNone/>
-                      </a:pPr>
                       <a:r>
-                        <a:rPr lang="en-US" sz="1100" b="0" i="0" u="none" strike="noStrike">
-                          <a:solidFill>
-                            <a:srgbClr val="000000"/>
-                          </a:solidFill>
-                          <a:effectLst/>
-                          <a:latin typeface="Aptos" panose="020B0004020202020204" pitchFamily="34" charset="0"/>
-                        </a:rPr>
+                        <a:rPr sz="1200"/>
                         <a:t>1</a:t>
                       </a:r>
                     </a:p>
@@ -21103,17 +19855,8 @@
                     <a:bodyPr/>
                     <a:lstStyle/>
                     <a:p>
-                      <a:pPr algn="l" rtl="0" fontAlgn="ctr">
-                        <a:buNone/>
-                      </a:pPr>
                       <a:r>
-                        <a:rPr lang="en-US" sz="1100" b="0" i="0" u="none" strike="noStrike" dirty="0">
-                          <a:solidFill>
-                            <a:srgbClr val="000000"/>
-                          </a:solidFill>
-                          <a:effectLst/>
-                          <a:latin typeface="Aptos" panose="020B0004020202020204" pitchFamily="34" charset="0"/>
-                        </a:rPr>
+                        <a:rPr sz="1200"/>
                         <a:t>0.533</a:t>
                       </a:r>
                     </a:p>
@@ -21165,17 +19908,8 @@
                     <a:bodyPr/>
                     <a:lstStyle/>
                     <a:p>
-                      <a:pPr algn="l" rtl="0" fontAlgn="ctr">
-                        <a:buNone/>
-                      </a:pPr>
                       <a:r>
-                        <a:rPr lang="en-US" sz="1100" b="0" i="0" u="none" strike="noStrike" dirty="0">
-                          <a:solidFill>
-                            <a:srgbClr val="000000"/>
-                          </a:solidFill>
-                          <a:effectLst/>
-                          <a:latin typeface="Aptos" panose="020B0004020202020204" pitchFamily="34" charset="0"/>
-                        </a:rPr>
+                        <a:rPr sz="1200" dirty="0"/>
                         <a:t>0.99</a:t>
                       </a:r>
                     </a:p>
@@ -21234,17 +19968,8 @@
                     <a:bodyPr/>
                     <a:lstStyle/>
                     <a:p>
-                      <a:pPr algn="l" rtl="0" fontAlgn="ctr">
-                        <a:buNone/>
-                      </a:pPr>
                       <a:r>
-                        <a:rPr lang="en-US" sz="1100" b="0" i="0" u="none" strike="noStrike">
-                          <a:solidFill>
-                            <a:srgbClr val="000000"/>
-                          </a:solidFill>
-                          <a:effectLst/>
-                          <a:latin typeface="Aptos" panose="020B0004020202020204" pitchFamily="34" charset="0"/>
-                        </a:rPr>
+                        <a:rPr sz="1200"/>
                         <a:t>DistilRoBERTa</a:t>
                       </a:r>
                     </a:p>
@@ -21296,18 +20021,9 @@
                     <a:bodyPr/>
                     <a:lstStyle/>
                     <a:p>
-                      <a:pPr algn="l" rtl="0" fontAlgn="ctr">
-                        <a:buNone/>
-                      </a:pPr>
                       <a:r>
-                        <a:rPr lang="en-US" sz="1100" b="0" i="0" u="none" strike="noStrike">
-                          <a:solidFill>
-                            <a:srgbClr val="000000"/>
-                          </a:solidFill>
-                          <a:effectLst/>
-                          <a:latin typeface="Aptos" panose="020B0004020202020204" pitchFamily="34" charset="0"/>
-                        </a:rPr>
-                        <a:t>0.788</a:t>
+                        <a:rPr sz="1200"/>
+                        <a:t>0.704</a:t>
                       </a:r>
                     </a:p>
                   </a:txBody>
@@ -21358,18 +20074,9 @@
                     <a:bodyPr/>
                     <a:lstStyle/>
                     <a:p>
-                      <a:pPr algn="l" rtl="0" fontAlgn="ctr">
-                        <a:buNone/>
-                      </a:pPr>
                       <a:r>
-                        <a:rPr lang="en-US" sz="1100" b="0" i="0" u="none" strike="noStrike">
-                          <a:solidFill>
-                            <a:srgbClr val="000000"/>
-                          </a:solidFill>
-                          <a:effectLst/>
-                          <a:latin typeface="Aptos" panose="020B0004020202020204" pitchFamily="34" charset="0"/>
-                        </a:rPr>
-                        <a:t>0.176</a:t>
+                        <a:rPr sz="1200"/>
+                        <a:t>0.186</a:t>
                       </a:r>
                     </a:p>
                   </a:txBody>
@@ -21420,17 +20127,8 @@
                     <a:bodyPr/>
                     <a:lstStyle/>
                     <a:p>
-                      <a:pPr algn="l" rtl="0" fontAlgn="ctr">
-                        <a:buNone/>
-                      </a:pPr>
                       <a:r>
-                        <a:rPr lang="en-US" sz="1100" b="0" i="0" u="none" strike="noStrike">
-                          <a:solidFill>
-                            <a:srgbClr val="000000"/>
-                          </a:solidFill>
-                          <a:effectLst/>
-                          <a:latin typeface="Aptos" panose="020B0004020202020204" pitchFamily="34" charset="0"/>
-                        </a:rPr>
+                        <a:rPr sz="1200"/>
                         <a:t>0.129</a:t>
                       </a:r>
                     </a:p>
@@ -21482,17 +20180,8 @@
                     <a:bodyPr/>
                     <a:lstStyle/>
                     <a:p>
-                      <a:pPr algn="l" rtl="0" fontAlgn="ctr">
-                        <a:buNone/>
-                      </a:pPr>
                       <a:r>
-                        <a:rPr lang="en-US" sz="1100" b="0" i="0" u="none" strike="noStrike">
-                          <a:solidFill>
-                            <a:srgbClr val="000000"/>
-                          </a:solidFill>
-                          <a:effectLst/>
-                          <a:latin typeface="Aptos" panose="020B0004020202020204" pitchFamily="34" charset="0"/>
-                        </a:rPr>
+                        <a:rPr sz="1200"/>
                         <a:t>0.75</a:t>
                       </a:r>
                     </a:p>
@@ -21544,18 +20233,9 @@
                     <a:bodyPr/>
                     <a:lstStyle/>
                     <a:p>
-                      <a:pPr algn="l" rtl="0" fontAlgn="ctr">
-                        <a:buNone/>
-                      </a:pPr>
                       <a:r>
-                        <a:rPr lang="en-US" sz="1100" b="0" i="0" u="none" strike="noStrike">
-                          <a:solidFill>
-                            <a:srgbClr val="000000"/>
-                          </a:solidFill>
-                          <a:effectLst/>
-                          <a:latin typeface="Aptos" panose="020B0004020202020204" pitchFamily="34" charset="0"/>
-                        </a:rPr>
-                        <a:t>0.08</a:t>
+                        <a:rPr sz="1200"/>
+                        <a:t>0.067</a:t>
                       </a:r>
                     </a:p>
                   </a:txBody>
@@ -21606,18 +20286,9 @@
                     <a:bodyPr/>
                     <a:lstStyle/>
                     <a:p>
-                      <a:pPr algn="l" rtl="0" fontAlgn="ctr">
-                        <a:buNone/>
-                      </a:pPr>
                       <a:r>
-                        <a:rPr lang="en-US" sz="1100" b="0" i="0" u="none" strike="noStrike" dirty="0">
-                          <a:solidFill>
-                            <a:srgbClr val="000000"/>
-                          </a:solidFill>
-                          <a:effectLst/>
-                          <a:latin typeface="Aptos" panose="020B0004020202020204" pitchFamily="34" charset="0"/>
-                        </a:rPr>
-                        <a:t>0.873</a:t>
+                        <a:rPr sz="1200" dirty="0"/>
+                        <a:t>0.877</a:t>
                       </a:r>
                     </a:p>
                   </a:txBody>

</xml_diff>